<commit_message>
Fact-check fix: FPT 2Q26 +14% YoY is NPATMI, not PBT
Press cross-check showed the +14% YoY growth in 2Q26 belongs to
NPATMI (VND2,568bn), with revenue -17% YoY on the basis change; PBT
was VND2,910bn with no comparable growth figure. Corrected on both
FPT slides (EN + VN) and in the stock-pick FPT growth cell.

Co-Authored-By: Claude Fable 5 <noreply@anthropic.com>
Claude-Session: https://claude.ai/code/session_01QPsxWfyBSmSQjUzo5EDnm5
</commit_message>
<xml_diff>
--- a/MASVN_RS_WM_2H26_outlook_Equity_VN_2026_STBFPT_24July2026.pptx
+++ b/MASVN_RS_WM_2H26_outlook_Equity_VN_2026_STBFPT_24July2026.pptx
@@ -29681,7 +29681,7 @@
                 <a:ea typeface="Noto Sans" panose="020B0502040504020204" pitchFamily="34" charset="0"/>
                 <a:cs typeface="Noto Sans" panose="020B0502040504020204" pitchFamily="34" charset="0"/>
               </a:rPr>
-              <a:t>Revenue reached VND 26,269bn (+12.6% YoY) and PBT VND 5,714bn (+18.1% YoY), completing 45%/49% of the FY26 plan; 2Q26 PBT was VND 2,910bn (+14% YoY). Technology remained the engine: revenue of VND 23,138bn (+15% YoY; 88% of group revenue) and PBT of VND 3,314bn (+16.9% YoY), with Global IT +13.4% and Domestic IT +22.5% in 6M26 on AI/digital-transformation demand and government digitalization spend. Education, investment &amp; others posted VND 3,131bn (-2.1% YoY).</a:t>
+              <a:t>Revenue reached VND 26,269bn (+12.6% YoY) and PBT VND 5,714bn (+18.1% YoY), completing 45%/49% of the FY26 plan; 2Q26 PBT was VND 2,910bn, with NPATMI of VND 2,568bn (+14% YoY; revenue -17% YoY on the basis change). Technology remained the engine: revenue of VND 23,138bn (+15% YoY; 88% of group revenue) and PBT of VND 3,314bn (+16.9% YoY), with Global IT +13.4% and Domestic IT +22.5% in 6M26 on AI/digital-transformation demand and government digitalization spend. Education, investment &amp; others posted VND 3,131bn (-2.1% YoY).</a:t>
             </a:r>
             <a:endParaRPr kumimoji="1" lang="en-US" altLang="ko-KR" sz="800" b="1" dirty="0">
               <a:solidFill>
@@ -38009,7 +38009,7 @@
                 <a:ea typeface="Noto Sans" panose="020B0502040504020204" pitchFamily="34" charset="0"/>
                 <a:cs typeface="Noto Sans" panose="020B0502040504020204" pitchFamily="34" charset="0"/>
               </a:rPr>
-              <a:t>Doanh thu đạt 26,269 tỷ đồng (+12.6% CK), LNTT 5,714 tỷ đồng (+18.1% CK), hoàn thành 45%/49% kế hoạch năm; LNTT Q2/2026 đạt 2,910 tỷ đồng (+14% CK). Khối Công nghệ tiếp tục là động lực chính: doanh thu 23,138 tỷ đồng (+15% CK; 88% doanh thu toàn tập đoàn), LNTT 3,314 tỷ đồng (+16.9% CK); CNTT nước ngoài +13.4% và CNTT trong nước +22.5% trong 6T26 nhờ nhu cầu AI/chuyển đổi số và chi tiêu số hóa của khối chính phủ. Mảng Giáo dục, đầu tư &amp; khác đạt 3,131 tỷ đồng (-2.1% CK).</a:t>
+              <a:t>Doanh thu đạt 26,269 tỷ đồng (+12.6% CK), LNTT 5,714 tỷ đồng (+18.1% CK), hoàn thành 45%/49% kế hoạch năm; LNTT Q2/2026 đạt 2,910 tỷ đồng, LNST-CĐTS đạt 2,568 tỷ đồng (+14% CK; doanh thu -17% CK do thay đổi chuẩn hợp nhất). Khối Công nghệ tiếp tục là động lực chính: doanh thu 23,138 tỷ đồng (+15% CK; 88% doanh thu toàn tập đoàn), LNTT 3,314 tỷ đồng (+16.9% CK); CNTT nước ngoài +13.4% và CNTT trong nước +22.5% trong 6T26 nhờ nhu cầu AI/chuyển đổi số và chi tiêu số hóa của khối chính phủ. Mảng Giáo dục, đầu tư &amp; khác đạt 3,131 tỷ đồng (-2.1% CK).</a:t>
             </a:r>
           </a:p>
           <a:p>

</xml_diff>

<commit_message>
Restructure FPT results text: label 1H26 cumulative vs 2Q26 alone
Rewrite the FPT results paragraph (deck EN/VN and stock-pick Growth
cell) into clearly labeled blocks — 1H26 cumulative, 2Q26 standalone
(with 1Q26 comparatives), and 1H26 segment detail. Also align the
stock-pick FY26F EPS growth to +14.9% (was +16.5%, computed on the
model's NPATMI rather than the Target Price sheet's).

Co-Authored-By: Claude Fable 5 <noreply@anthropic.com>
Claude-Session: https://claude.ai/code/session_01QPsxWfyBSmSQjUzo5EDnm5
</commit_message>
<xml_diff>
--- a/MASVN_RS_WM_2H26_outlook_Equity_VN_2026_STBFPT_24July2026.pptx
+++ b/MASVN_RS_WM_2H26_outlook_Equity_VN_2026_STBFPT_24July2026.pptx
@@ -29681,7 +29681,7 @@
                 <a:ea typeface="Noto Sans" panose="020B0502040504020204" pitchFamily="34" charset="0"/>
                 <a:cs typeface="Noto Sans" panose="020B0502040504020204" pitchFamily="34" charset="0"/>
               </a:rPr>
-              <a:t>Revenue reached VND 26,269bn (+12.6% YoY) and PBT VND 5,714bn (+18.1% YoY), completing 45%/49% of the FY26 plan; 2Q26 PBT was VND 2,910bn, with NPATMI of VND 2,568bn (+14% YoY; revenue -17% YoY on the basis change). Technology remained the engine: revenue of VND 23,138bn (+15% YoY; 88% of group revenue) and PBT of VND 3,314bn (+16.9% YoY), with Global IT +13.4% and Domestic IT +22.5% in 6M26 on AI/digital-transformation demand and government digitalization spend. Education, investment &amp; others posted VND 3,131bn (-2.1% YoY).</a:t>
+              <a:t>1H26 (cumulative): revenue VND 26,269bn (+12.6% YoY) and PBT VND 5,714bn (+18.1% YoY), completing 45%/49% of the FY26 revenue/PBT plan. 2Q26 alone: revenue VND 13,789bn, PBT VND 2,910bn (vs VND 12,480bn / VND 2,804bn in 1Q26) and NPATMI VND 2,568bn (+14% YoY); reported 2Q26 revenue fell 17% YoY purely on the Telecom deconsolidation. By segment (1H26): Technology revenue VND 23,138bn (+15% YoY; 88% of group revenue) and PBT VND 3,314bn (+16.9% YoY), with Global IT +13.4% and Domestic IT +22.5%; Education, investment &amp; others VND 3,131bn (-2.1% YoY).</a:t>
             </a:r>
             <a:endParaRPr kumimoji="1" lang="en-US" altLang="ko-KR" sz="800" b="1" dirty="0">
               <a:solidFill>
@@ -38009,7 +38009,7 @@
                 <a:ea typeface="Noto Sans" panose="020B0502040504020204" pitchFamily="34" charset="0"/>
                 <a:cs typeface="Noto Sans" panose="020B0502040504020204" pitchFamily="34" charset="0"/>
               </a:rPr>
-              <a:t>Doanh thu đạt 26,269 tỷ đồng (+12.6% CK), LNTT 5,714 tỷ đồng (+18.1% CK), hoàn thành 45%/49% kế hoạch năm; LNTT Q2/2026 đạt 2,910 tỷ đồng, LNST-CĐTS đạt 2,568 tỷ đồng (+14% CK; doanh thu -17% CK do thay đổi chuẩn hợp nhất). Khối Công nghệ tiếp tục là động lực chính: doanh thu 23,138 tỷ đồng (+15% CK; 88% doanh thu toàn tập đoàn), LNTT 3,314 tỷ đồng (+16.9% CK); CNTT nước ngoài +13.4% và CNTT trong nước +22.5% trong 6T26 nhờ nhu cầu AI/chuyển đổi số và chi tiêu số hóa của khối chính phủ. Mảng Giáo dục, đầu tư &amp; khác đạt 3,131 tỷ đồng (-2.1% CK).</a:t>
+              <a:t>Lũy kế 1H26: doanh thu 26,269 tỷ đồng (+12.6% CK), LNTT 5,714 tỷ đồng (+18.1% CK), hoàn thành 45%/49% kế hoạch doanh thu/LNTT năm 2026. Riêng Q2/2026: doanh thu 13,789 tỷ đồng, LNTT 2,910 tỷ đồng (so với 12,480 tỷ / 2,804 tỷ trong Q1/2026), LNST-CĐTS 2,568 tỷ đồng (+14% CK); doanh thu Q2/2026 giảm 17% CK hoàn toàn do FPT Telecom không còn hợp nhất. Theo mảng (1H26): khối Công nghệ đạt doanh thu 23,138 tỷ đồng (+15% CK; 88% doanh thu toàn tập đoàn), LNTT 3,314 tỷ đồng (+16.9% CK); CNTT nước ngoài +13.4%, CNTT trong nước +22.5%; mảng Giáo dục, đầu tư &amp; khác đạt 3,131 tỷ đồng (-2.1% CK).</a:t>
             </a:r>
           </a:p>
           <a:p>

</xml_diff>

<commit_message>
Cascade recalibrated FPT forecasts into deck and stock-pick file
Propagate the 2H26-NPATMI-+16% recalibration (FY26F 10,898 +15.2%,
FY27F 12,642 +16.0%, EPS 6,021/+18.7%) into the STB+FPT deck (FY
table, summary box, narrative on EN and VN slides) and the Aug26
stock-pick workbook (FPT row and Target Price sheet), including
v2-model revisions to OP/PBT/BS lines the deck predated.

Co-Authored-By: Claude Fable 5 <noreply@anthropic.com>
Claude-Session: https://claude.ai/code/session_01QPsxWfyBSmSQjUzo5EDnm5
</commit_message>
<xml_diff>
--- a/MASVN_RS_WM_2H26_outlook_Equity_VN_2026_STBFPT_24July2026.pptx
+++ b/MASVN_RS_WM_2H26_outlook_Equity_VN_2026_STBFPT_24July2026.pptx
@@ -28155,7 +28155,7 @@
                           <a:ea typeface="Noto Sans" panose="020B0502040504020204" pitchFamily="34" charset="0"/>
                           <a:cs typeface="Noto Sans" panose="020B0502040504020204" pitchFamily="34" charset="0"/>
                         </a:rPr>
-                        <a:t>10,555</a:t>
+                        <a:t>10,898</a:t>
                       </a:r>
                     </a:p>
                   </a:txBody>
@@ -28320,7 +28320,7 @@
                           <a:ea typeface="Noto Sans" panose="020B0502040504020204" pitchFamily="34" charset="0"/>
                           <a:cs typeface="Noto Sans" panose="020B0502040504020204" pitchFamily="34" charset="0"/>
                         </a:rPr>
-                        <a:t>14.9</a:t>
+                        <a:t>18.7</a:t>
                       </a:r>
                     </a:p>
                   </a:txBody>
@@ -28404,7 +28404,7 @@
                           <a:ea typeface="Noto Sans" panose="020B0502040504020204" pitchFamily="34" charset="0"/>
                           <a:cs typeface="Noto Sans" panose="020B0502040504020204" pitchFamily="34" charset="0"/>
                         </a:rPr>
-                        <a:t>15.7</a:t>
+                        <a:t>15.2</a:t>
                       </a:r>
                     </a:p>
                   </a:txBody>
@@ -29726,7 +29726,7 @@
                 <a:ea typeface="Noto Sans" panose="020B0502040504020204" pitchFamily="34" charset="0"/>
                 <a:cs typeface="Noto Sans" panose="020B0502040504020204" pitchFamily="34" charset="0"/>
               </a:rPr>
-              <a:t>From FY26, FPT Telecom is accounted for under the equity method (2025 restated for comparison). Reported revenue therefore steps down (FY26F: VND 57,195bn) while associate income (~VND 2.9tn in FY26F) flows through the equity-method line — lifting net margin to ~19% and reducing minority leakage, so EPS grows faster than NPATMI (FY26F: +14.9% vs +11.5%).</a:t>
+              <a:t>From FY26, FPT Telecom is accounted for under the equity method (2025 restated for comparison). Reported revenue therefore steps down (FY26F: VND 57,195bn) while associate income (~VND 2.9tn in FY26F) flows through the equity-method line — lifting net margin to ~19% and reducing minority leakage, so EPS grows faster than NPATMI (FY26F: +18.7% vs +15.2%).</a:t>
             </a:r>
             <a:endParaRPr kumimoji="1" lang="en-US" altLang="ko-KR" sz="800" b="1" dirty="0">
               <a:solidFill>
@@ -29771,7 +29771,7 @@
                 <a:ea typeface="Noto Sans" panose="020B0502040504020204" pitchFamily="34" charset="0"/>
                 <a:cs typeface="Noto Sans" panose="020B0502040504020204" pitchFamily="34" charset="0"/>
               </a:rPr>
-              <a:t>We forecast FY26F NPATMI of VND 10,555bn (+11.5% YoY) and FY27F of VND 12,447bn (+17.9% YoY), driven by a Global IT growth reacceleration (FY27F: +16.7%). Our DCF (FCFF)-based target price is VND 91,570; at the current two-year-low price of VND 62,900 (24/07/26), FPT trades at just 10.8x 2026F P/E versus a 5-year median above 18x, implying a 46% expected return (BUY). Risks: soft US/global IT spending, tariff-related deal delays, and JPY/USD FX swings.</a:t>
+              <a:t>We forecast FY26F NPATMI of VND 10,898bn (+15.2% YoY) and FY27F of VND 12,642bn (+16.0% YoY), driven by a Global IT growth reacceleration (FY27F: +16.7%). Our DCF (FCFF)-based target price is VND 91,570; at the current two-year-low price of VND 62,900 (24/07/26), FPT trades at just 10.4x 2026F P/E versus a 5-year median above 18x, implying a 46% expected return (BUY). Risks: soft US/global IT spending, tariff-related deal delays, and JPY/USD FX swings.</a:t>
             </a:r>
           </a:p>
           <a:p>
@@ -30851,7 +30851,7 @@
                           <a:effectLst/>
                           <a:latin typeface="Noto Sans" panose="020B0502040504020204" pitchFamily="34" charset="0"/>
                         </a:rPr>
-                        <a:t>9,257</a:t>
+                        <a:t>9,757</a:t>
                       </a:r>
                     </a:p>
                   </a:txBody>
@@ -30897,7 +30897,7 @@
                           <a:effectLst/>
                           <a:latin typeface="Noto Sans" panose="020B0502040504020204" pitchFamily="34" charset="0"/>
                         </a:rPr>
-                        <a:t>10,601</a:t>
+                        <a:t>10,802</a:t>
                       </a:r>
                     </a:p>
                   </a:txBody>
@@ -31177,7 +31177,7 @@
                           <a:effectLst/>
                           <a:latin typeface="Noto Sans" panose="020B0502040504020204" pitchFamily="34" charset="0"/>
                         </a:rPr>
-                        <a:t>12,770</a:t>
+                        <a:t>13,016</a:t>
                       </a:r>
                     </a:p>
                   </a:txBody>
@@ -31226,7 +31226,7 @@
                           <a:effectLst/>
                           <a:latin typeface="Noto Sans" panose="020B0502040504020204" pitchFamily="34" charset="0"/>
                         </a:rPr>
-                        <a:t>14,796</a:t>
+                        <a:t>15,121</a:t>
                       </a:r>
                     </a:p>
                   </a:txBody>
@@ -31272,7 +31272,7 @@
                           <a:effectLst/>
                           <a:latin typeface="Noto Sans" panose="020B0502040504020204" pitchFamily="34" charset="0"/>
                         </a:rPr>
-                        <a:t>16,989</a:t>
+                        <a:t>17,015</a:t>
                       </a:r>
                     </a:p>
                   </a:txBody>
@@ -31509,7 +31509,7 @@
                           <a:effectLst/>
                           <a:latin typeface="Noto Sans" panose="020B0502040504020204" pitchFamily="34" charset="0"/>
                         </a:rPr>
-                        <a:t>10,555</a:t>
+                        <a:t>10,898</a:t>
                       </a:r>
                     </a:p>
                   </a:txBody>
@@ -31558,7 +31558,7 @@
                           <a:effectLst/>
                           <a:latin typeface="Noto Sans" panose="020B0502040504020204" pitchFamily="34" charset="0"/>
                         </a:rPr>
-                        <a:t>12,447</a:t>
+                        <a:t>12,642</a:t>
                       </a:r>
                     </a:p>
                   </a:txBody>
@@ -31604,7 +31604,7 @@
                           <a:effectLst/>
                           <a:latin typeface="Noto Sans" panose="020B0502040504020204" pitchFamily="34" charset="0"/>
                         </a:rPr>
-                        <a:t>14,204</a:t>
+                        <a:t>14,225</a:t>
                       </a:r>
                     </a:p>
                   </a:txBody>
@@ -31841,7 +31841,7 @@
                           <a:effectLst/>
                           <a:latin typeface="Noto Sans" panose="020B0502040504020204" pitchFamily="34" charset="0"/>
                         </a:rPr>
-                        <a:t>5,831</a:t>
+                        <a:t>6,021</a:t>
                       </a:r>
                     </a:p>
                   </a:txBody>
@@ -31890,7 +31890,7 @@
                           <a:effectLst/>
                           <a:latin typeface="Noto Sans" panose="020B0502040504020204" pitchFamily="34" charset="0"/>
                         </a:rPr>
-                        <a:t>6,877</a:t>
+                        <a:t>6,984</a:t>
                       </a:r>
                     </a:p>
                   </a:txBody>
@@ -31936,7 +31936,7 @@
                           <a:effectLst/>
                           <a:latin typeface="Noto Sans" panose="020B0502040504020204" pitchFamily="34" charset="0"/>
                         </a:rPr>
-                        <a:t>7,847</a:t>
+                        <a:t>7,859</a:t>
                       </a:r>
                     </a:p>
                   </a:txBody>
@@ -32173,7 +32173,7 @@
                           <a:effectLst/>
                           <a:latin typeface="Noto Sans" panose="020B0502040504020204" pitchFamily="34" charset="0"/>
                         </a:rPr>
-                        <a:t>27.1</a:t>
+                        <a:t>27.4</a:t>
                       </a:r>
                     </a:p>
                   </a:txBody>
@@ -32222,7 +32222,7 @@
                           <a:effectLst/>
                           <a:latin typeface="Noto Sans" panose="020B0502040504020204" pitchFamily="34" charset="0"/>
                         </a:rPr>
-                        <a:t>26.7</a:t>
+                        <a:t>27.0</a:t>
                       </a:r>
                     </a:p>
                   </a:txBody>
@@ -32268,7 +32268,7 @@
                           <a:effectLst/>
                           <a:latin typeface="Noto Sans" panose="020B0502040504020204" pitchFamily="34" charset="0"/>
                         </a:rPr>
-                        <a:t>25.9</a:t>
+                        <a:t>25.7</a:t>
                       </a:r>
                     </a:p>
                   </a:txBody>
@@ -32505,7 +32505,7 @@
                           <a:effectLst/>
                           <a:latin typeface="Noto Sans" panose="020B0502040504020204" pitchFamily="34" charset="0"/>
                         </a:rPr>
-                        <a:t>15.7</a:t>
+                        <a:t>15.2</a:t>
                       </a:r>
                     </a:p>
                   </a:txBody>
@@ -32554,7 +32554,7 @@
                           <a:effectLst/>
                           <a:latin typeface="Noto Sans" panose="020B0502040504020204" pitchFamily="34" charset="0"/>
                         </a:rPr>
-                        <a:t>13.3</a:t>
+                        <a:t>13.1</a:t>
                       </a:r>
                     </a:p>
                   </a:txBody>
@@ -33185,7 +33185,7 @@
                           <a:effectLst/>
                           <a:latin typeface="Noto Sans" panose="020B0502040504020204" pitchFamily="34" charset="0"/>
                         </a:rPr>
-                        <a:t>91,667</a:t>
+                        <a:t>91,894</a:t>
                       </a:r>
                     </a:p>
                   </a:txBody>
@@ -33238,7 +33238,7 @@
                           <a:effectLst/>
                           <a:latin typeface="Noto Sans" panose="020B0502040504020204" pitchFamily="34" charset="0"/>
                         </a:rPr>
-                        <a:t>102,379</a:t>
+                        <a:t>102,871</a:t>
                       </a:r>
                     </a:p>
                   </a:txBody>
@@ -33288,7 +33288,7 @@
                           <a:effectLst/>
                           <a:latin typeface="Noto Sans" panose="020B0502040504020204" pitchFamily="34" charset="0"/>
                         </a:rPr>
-                        <a:t>114,767</a:t>
+                        <a:t>115,272</a:t>
                       </a:r>
                     </a:p>
                   </a:txBody>
@@ -33551,7 +33551,7 @@
                           <a:effectLst/>
                           <a:latin typeface="Noto Sans" panose="020B0502040504020204" pitchFamily="34" charset="0"/>
                         </a:rPr>
-                        <a:t>49,927</a:t>
+                        <a:t>50,111</a:t>
                       </a:r>
                     </a:p>
                   </a:txBody>
@@ -33604,7 +33604,7 @@
                           <a:effectLst/>
                           <a:latin typeface="Noto Sans" panose="020B0502040504020204" pitchFamily="34" charset="0"/>
                         </a:rPr>
-                        <a:t>57,775</a:t>
+                        <a:t>58,225</a:t>
                       </a:r>
                     </a:p>
                   </a:txBody>
@@ -33654,7 +33654,7 @@
                           <a:effectLst/>
                           <a:latin typeface="Noto Sans" panose="020B0502040504020204" pitchFamily="34" charset="0"/>
                         </a:rPr>
-                        <a:t>67,380</a:t>
+                        <a:t>67,850</a:t>
                       </a:r>
                     </a:p>
                   </a:txBody>
@@ -33911,7 +33911,7 @@
                           <a:effectLst/>
                           <a:latin typeface="Noto Sans" panose="020B0502040504020204" pitchFamily="34" charset="0"/>
                         </a:rPr>
-                        <a:t>24,978</a:t>
+                        <a:t>25,082</a:t>
                       </a:r>
                     </a:p>
                   </a:txBody>
@@ -33964,7 +33964,7 @@
                           <a:effectLst/>
                           <a:latin typeface="Noto Sans" panose="020B0502040504020204" pitchFamily="34" charset="0"/>
                         </a:rPr>
-                        <a:t>29,464</a:t>
+                        <a:t>29,728</a:t>
                       </a:r>
                     </a:p>
                   </a:txBody>
@@ -34014,7 +34014,7 @@
                           <a:effectLst/>
                           <a:latin typeface="Noto Sans" panose="020B0502040504020204" pitchFamily="34" charset="0"/>
                         </a:rPr>
-                        <a:t>34,963</a:t>
+                        <a:t>35,245</a:t>
                       </a:r>
                     </a:p>
                   </a:txBody>
@@ -35487,7 +35487,7 @@
                           <a:ea typeface="Noto Sans" panose="020B0502040504020204" pitchFamily="34" charset="0"/>
                           <a:cs typeface="Noto Sans" panose="020B0502040504020204" pitchFamily="34" charset="0"/>
                         </a:rPr>
-                        <a:t>10,555</a:t>
+                        <a:t>10,898</a:t>
                       </a:r>
                     </a:p>
                   </a:txBody>
@@ -35844,7 +35844,7 @@
                           <a:ea typeface="Noto Sans" panose="020B0502040504020204" pitchFamily="34" charset="0"/>
                           <a:cs typeface="Noto Sans" panose="020B0502040504020204" pitchFamily="34" charset="0"/>
                         </a:rPr>
-                        <a:t>14.9</a:t>
+                        <a:t>18.7</a:t>
                       </a:r>
                     </a:p>
                   </a:txBody>
@@ -35928,7 +35928,7 @@
                           <a:ea typeface="Noto Sans" panose="020B0502040504020204" pitchFamily="34" charset="0"/>
                           <a:cs typeface="Noto Sans" panose="020B0502040504020204" pitchFamily="34" charset="0"/>
                         </a:rPr>
-                        <a:t>15.7</a:t>
+                        <a:t>15.2</a:t>
                       </a:r>
                     </a:p>
                   </a:txBody>
@@ -38046,7 +38046,7 @@
                 <a:ea typeface="Noto Sans" panose="020B0502040504020204" pitchFamily="34" charset="0"/>
                 <a:cs typeface="Noto Sans" panose="020B0502040504020204" pitchFamily="34" charset="0"/>
               </a:rPr>
-              <a:t>Từ FY26, FPT Telecom được hạch toán theo phương pháp vốn chủ sở hữu (số liệu 2025 được điều chỉnh lại để so sánh). Doanh thu báo cáo do đó giảm về 57,195 tỷ đồng cho FY26F, trong khi lợi nhuận từ công ty liên kết (~2.9 nghìn tỷ FY26F) ghi nhận qua dòng liên doanh liên kết — giúp biên LN ròng tăng lên ~19% và giảm lợi ích cổ đông thiểu số, nhờ đó EPS tăng nhanh hơn LNST-CĐTS (FY26F: +14.9% so với +11.5%).</a:t>
+              <a:t>Từ FY26, FPT Telecom được hạch toán theo phương pháp vốn chủ sở hữu (số liệu 2025 được điều chỉnh lại để so sánh). Doanh thu báo cáo do đó giảm về 57,195 tỷ đồng cho FY26F, trong khi lợi nhuận từ công ty liên kết (~2.9 nghìn tỷ FY26F) ghi nhận qua dòng liên doanh liên kết — giúp biên LN ròng tăng lên ~19% và giảm lợi ích cổ đông thiểu số, nhờ đó EPS tăng nhanh hơn LNST-CĐTS (FY26F: +18.7% so với +15.2%).</a:t>
             </a:r>
           </a:p>
           <a:p>
@@ -38083,7 +38083,7 @@
                 <a:ea typeface="Noto Sans" panose="020B0502040504020204" pitchFamily="34" charset="0"/>
                 <a:cs typeface="Noto Sans" panose="020B0502040504020204" pitchFamily="34" charset="0"/>
               </a:rPr>
-              <a:t>Chúng tôi dự phóng LNST-CĐTS FY26F đạt 10,555 tỷ đồng (+11.5% CK) và FY27F đạt 12,447 tỷ đồng (+17.9% CK), dẫn dắt bởi đà tăng tốc trở lại của CNTT nước ngoài (FY27F: +16.7%). Giá mục tiêu theo DCF (FCFF) là 91,570 đồng/cp; tại thị giá đáy 2 năm 62,900 đồng (24/07/26), FPT giao dịch ở mức 10.8x P/E 2026F so với trung vị 5 năm trên 18x, tương ứng lợi nhuận kỳ vọng 46% (MUA). Rủi ro: chi tiêu CNTT tại Mỹ/toàn cầu suy yếu, trì hoãn hợp đồng do thuế quan, biến động tỷ giá JPY/USD.</a:t>
+              <a:t>Chúng tôi dự phóng LNST-CĐTS FY26F đạt 10,898 tỷ đồng (+15.2% CK) và FY27F đạt 12,642 tỷ đồng (+16.0% CK), dẫn dắt bởi đà tăng tốc trở lại của CNTT nước ngoài (FY27F: +16.7%). Giá mục tiêu theo DCF (FCFF) là 91,570 đồng/cp; tại thị giá đáy 2 năm 62,900 đồng (24/07/26), FPT giao dịch ở mức 10.4x P/E 2026F so với trung vị 5 năm trên 18x, tương ứng lợi nhuận kỳ vọng 46% (MUA). Rủi ro: chi tiêu CNTT tại Mỹ/toàn cầu suy yếu, trì hoãn hợp đồng do thuế quan, biến động tỷ giá JPY/USD.</a:t>
             </a:r>
             <a:endParaRPr kumimoji="1" lang="en-US" altLang="ko-KR" sz="800" b="0" dirty="0">
               <a:solidFill>
@@ -39142,7 +39142,7 @@
                           <a:effectLst/>
                           <a:latin typeface="Noto Sans" panose="020B0502040504020204" pitchFamily="34" charset="0"/>
                         </a:rPr>
-                        <a:t>9,257</a:t>
+                        <a:t>9,757</a:t>
                       </a:r>
                     </a:p>
                   </a:txBody>
@@ -39188,7 +39188,7 @@
                           <a:effectLst/>
                           <a:latin typeface="Noto Sans" panose="020B0502040504020204" pitchFamily="34" charset="0"/>
                         </a:rPr>
-                        <a:t>10,601</a:t>
+                        <a:t>10,802</a:t>
                       </a:r>
                     </a:p>
                   </a:txBody>
@@ -39468,7 +39468,7 @@
                           <a:effectLst/>
                           <a:latin typeface="Noto Sans" panose="020B0502040504020204" pitchFamily="34" charset="0"/>
                         </a:rPr>
-                        <a:t>12,770</a:t>
+                        <a:t>13,016</a:t>
                       </a:r>
                     </a:p>
                   </a:txBody>
@@ -39517,7 +39517,7 @@
                           <a:effectLst/>
                           <a:latin typeface="Noto Sans" panose="020B0502040504020204" pitchFamily="34" charset="0"/>
                         </a:rPr>
-                        <a:t>14,796</a:t>
+                        <a:t>15,121</a:t>
                       </a:r>
                     </a:p>
                   </a:txBody>
@@ -39563,7 +39563,7 @@
                           <a:effectLst/>
                           <a:latin typeface="Noto Sans" panose="020B0502040504020204" pitchFamily="34" charset="0"/>
                         </a:rPr>
-                        <a:t>16,989</a:t>
+                        <a:t>17,015</a:t>
                       </a:r>
                     </a:p>
                   </a:txBody>
@@ -39800,7 +39800,7 @@
                           <a:effectLst/>
                           <a:latin typeface="Noto Sans" panose="020B0502040504020204" pitchFamily="34" charset="0"/>
                         </a:rPr>
-                        <a:t>10,555</a:t>
+                        <a:t>10,898</a:t>
                       </a:r>
                     </a:p>
                   </a:txBody>
@@ -39849,7 +39849,7 @@
                           <a:effectLst/>
                           <a:latin typeface="Noto Sans" panose="020B0502040504020204" pitchFamily="34" charset="0"/>
                         </a:rPr>
-                        <a:t>12,447</a:t>
+                        <a:t>12,642</a:t>
                       </a:r>
                     </a:p>
                   </a:txBody>
@@ -39895,7 +39895,7 @@
                           <a:effectLst/>
                           <a:latin typeface="Noto Sans" panose="020B0502040504020204" pitchFamily="34" charset="0"/>
                         </a:rPr>
-                        <a:t>14,204</a:t>
+                        <a:t>14,225</a:t>
                       </a:r>
                     </a:p>
                   </a:txBody>
@@ -40132,7 +40132,7 @@
                           <a:effectLst/>
                           <a:latin typeface="Noto Sans" panose="020B0502040504020204" pitchFamily="34" charset="0"/>
                         </a:rPr>
-                        <a:t>5,831</a:t>
+                        <a:t>6,021</a:t>
                       </a:r>
                     </a:p>
                   </a:txBody>
@@ -40181,7 +40181,7 @@
                           <a:effectLst/>
                           <a:latin typeface="Noto Sans" panose="020B0502040504020204" pitchFamily="34" charset="0"/>
                         </a:rPr>
-                        <a:t>6,877</a:t>
+                        <a:t>6,984</a:t>
                       </a:r>
                     </a:p>
                   </a:txBody>
@@ -40227,7 +40227,7 @@
                           <a:effectLst/>
                           <a:latin typeface="Noto Sans" panose="020B0502040504020204" pitchFamily="34" charset="0"/>
                         </a:rPr>
-                        <a:t>7,847</a:t>
+                        <a:t>7,859</a:t>
                       </a:r>
                     </a:p>
                   </a:txBody>
@@ -40464,7 +40464,7 @@
                           <a:effectLst/>
                           <a:latin typeface="Noto Sans" panose="020B0502040504020204" pitchFamily="34" charset="0"/>
                         </a:rPr>
-                        <a:t>27.1</a:t>
+                        <a:t>27.4</a:t>
                       </a:r>
                     </a:p>
                   </a:txBody>
@@ -40513,7 +40513,7 @@
                           <a:effectLst/>
                           <a:latin typeface="Noto Sans" panose="020B0502040504020204" pitchFamily="34" charset="0"/>
                         </a:rPr>
-                        <a:t>26.7</a:t>
+                        <a:t>27.0</a:t>
                       </a:r>
                     </a:p>
                   </a:txBody>
@@ -40559,7 +40559,7 @@
                           <a:effectLst/>
                           <a:latin typeface="Noto Sans" panose="020B0502040504020204" pitchFamily="34" charset="0"/>
                         </a:rPr>
-                        <a:t>25.9</a:t>
+                        <a:t>25.7</a:t>
                       </a:r>
                     </a:p>
                   </a:txBody>
@@ -40796,7 +40796,7 @@
                           <a:effectLst/>
                           <a:latin typeface="Noto Sans" panose="020B0502040504020204" pitchFamily="34" charset="0"/>
                         </a:rPr>
-                        <a:t>15.7</a:t>
+                        <a:t>15.2</a:t>
                       </a:r>
                     </a:p>
                   </a:txBody>
@@ -40845,7 +40845,7 @@
                           <a:effectLst/>
                           <a:latin typeface="Noto Sans" panose="020B0502040504020204" pitchFamily="34" charset="0"/>
                         </a:rPr>
-                        <a:t>13.3</a:t>
+                        <a:t>13.1</a:t>
                       </a:r>
                     </a:p>
                   </a:txBody>
@@ -41485,7 +41485,7 @@
                           <a:effectLst/>
                           <a:latin typeface="Noto Sans" panose="020B0502040504020204" pitchFamily="34" charset="0"/>
                         </a:rPr>
-                        <a:t>91,667</a:t>
+                        <a:t>91,894</a:t>
                       </a:r>
                     </a:p>
                   </a:txBody>
@@ -41538,7 +41538,7 @@
                           <a:effectLst/>
                           <a:latin typeface="Noto Sans" panose="020B0502040504020204" pitchFamily="34" charset="0"/>
                         </a:rPr>
-                        <a:t>102,379</a:t>
+                        <a:t>102,871</a:t>
                       </a:r>
                     </a:p>
                   </a:txBody>
@@ -41588,7 +41588,7 @@
                           <a:effectLst/>
                           <a:latin typeface="Noto Sans" panose="020B0502040504020204" pitchFamily="34" charset="0"/>
                         </a:rPr>
-                        <a:t>114,767</a:t>
+                        <a:t>115,272</a:t>
                       </a:r>
                     </a:p>
                   </a:txBody>
@@ -41854,7 +41854,7 @@
                           <a:effectLst/>
                           <a:latin typeface="Noto Sans" panose="020B0502040504020204" pitchFamily="34" charset="0"/>
                         </a:rPr>
-                        <a:t>49,927</a:t>
+                        <a:t>50,111</a:t>
                       </a:r>
                     </a:p>
                   </a:txBody>
@@ -41907,7 +41907,7 @@
                           <a:effectLst/>
                           <a:latin typeface="Noto Sans" panose="020B0502040504020204" pitchFamily="34" charset="0"/>
                         </a:rPr>
-                        <a:t>57,775</a:t>
+                        <a:t>58,225</a:t>
                       </a:r>
                     </a:p>
                   </a:txBody>
@@ -41957,7 +41957,7 @@
                           <a:effectLst/>
                           <a:latin typeface="Noto Sans" panose="020B0502040504020204" pitchFamily="34" charset="0"/>
                         </a:rPr>
-                        <a:t>67,380</a:t>
+                        <a:t>67,850</a:t>
                       </a:r>
                     </a:p>
                   </a:txBody>
@@ -42214,7 +42214,7 @@
                           <a:effectLst/>
                           <a:latin typeface="Noto Sans" panose="020B0502040504020204" pitchFamily="34" charset="0"/>
                         </a:rPr>
-                        <a:t>24,978</a:t>
+                        <a:t>25,082</a:t>
                       </a:r>
                     </a:p>
                   </a:txBody>
@@ -42267,7 +42267,7 @@
                           <a:effectLst/>
                           <a:latin typeface="Noto Sans" panose="020B0502040504020204" pitchFamily="34" charset="0"/>
                         </a:rPr>
-                        <a:t>29,464</a:t>
+                        <a:t>29,728</a:t>
                       </a:r>
                     </a:p>
                   </a:txBody>
@@ -42317,7 +42317,7 @@
                           <a:effectLst/>
                           <a:latin typeface="Noto Sans" panose="020B0502040504020204" pitchFamily="34" charset="0"/>
                         </a:rPr>
-                        <a:t>34,963</a:t>
+                        <a:t>35,245</a:t>
                       </a:r>
                     </a:p>
                   </a:txBody>

</xml_diff>

<commit_message>
Recalibrate FPT FY26F to NPATMI +15.0% via Domestic IT revert
Analyst call: Domestic IT +21% too aggressive, FY26F NPATMI growth to
15%. Root cause of the 19% drift documented: Revenue!J40 headcount is
hardcoded (45,000), so incremental Domestic IT revenue carried ~72%
gross margin and converted ~44% to NPATMI.

Solved exactly against a validated replication of the model's P&L chain
(zero error vs cached values on all three forecast years):
Scenarios!H17 0.2095 -> 0.126858 (FY26F Domestic IT +12.69%, 2H26
implied +6.7%); I45/J45 re-solved to 4.857%/5.284% to hold FY27F/28F at
+16.0%/+15.5%. Results: NPATMI 10,884/12,625/14,582, EPS 6,013 (+18.5%)
/6,975/8,056. Cascaded to deck (FY table, summary box, narrative EN+VN)
and stock-pick (FPT row + Target Price sheet).

Co-Authored-By: Claude Fable 5 <noreply@anthropic.com>
Claude-Session: https://claude.ai/code/session_01QPsxWfyBSmSQjUzo5EDnm5
</commit_message>
<xml_diff>
--- a/MASVN_RS_WM_2H26_outlook_Equity_VN_2026_STBFPT_24July2026.pptx
+++ b/MASVN_RS_WM_2H26_outlook_Equity_VN_2026_STBFPT_24July2026.pptx
@@ -28155,7 +28155,7 @@
                           <a:ea typeface="Noto Sans" panose="020B0502040504020204" pitchFamily="34" charset="0"/>
                           <a:cs typeface="Noto Sans" panose="020B0502040504020204" pitchFamily="34" charset="0"/>
                         </a:rPr>
-                        <a:t>10,898</a:t>
+                        <a:t>10,884</a:t>
                       </a:r>
                     </a:p>
                   </a:txBody>
@@ -28320,7 +28320,7 @@
                           <a:ea typeface="Noto Sans" panose="020B0502040504020204" pitchFamily="34" charset="0"/>
                           <a:cs typeface="Noto Sans" panose="020B0502040504020204" pitchFamily="34" charset="0"/>
                         </a:rPr>
-                        <a:t>18.7</a:t>
+                        <a:t>18.5</a:t>
                       </a:r>
                     </a:p>
                   </a:txBody>
@@ -29726,7 +29726,7 @@
                 <a:ea typeface="Noto Sans" panose="020B0502040504020204" pitchFamily="34" charset="0"/>
                 <a:cs typeface="Noto Sans" panose="020B0502040504020204" pitchFamily="34" charset="0"/>
               </a:rPr>
-              <a:t>From FY26, FPT Telecom is accounted for under the equity method (2025 restated for comparison). Reported revenue therefore steps down (FY26F: VND 57,195bn) while associate income (~VND 2.9tn in FY26F) flows through the equity-method line — lifting net margin to ~19% and reducing minority leakage, so EPS grows faster than NPATMI (FY26F: +18.7% vs +15.2%).</a:t>
+              <a:t>From FY26, FPT Telecom is accounted for under the equity method (2025 restated for comparison). Reported revenue therefore steps down (FY26F: VND 57,195bn) while associate income (~VND 2.9tn in FY26F) flows through the equity-method line — lifting net margin to ~19% and reducing minority leakage, so EPS grows faster than NPATMI (FY26F: +18.5% vs +15.0%).</a:t>
             </a:r>
             <a:endParaRPr kumimoji="1" lang="en-US" altLang="ko-KR" sz="800" b="1" dirty="0">
               <a:solidFill>
@@ -29771,7 +29771,7 @@
                 <a:ea typeface="Noto Sans" panose="020B0502040504020204" pitchFamily="34" charset="0"/>
                 <a:cs typeface="Noto Sans" panose="020B0502040504020204" pitchFamily="34" charset="0"/>
               </a:rPr>
-              <a:t>We forecast FY26F NPATMI of VND 10,898bn (+15.2% YoY) and FY27F of VND 12,642bn (+16.0% YoY), driven by a Global IT growth reacceleration (FY27F: +16.7%). Our DCF (FCFF)-based target price is VND 91,570; at the current two-year-low price of VND 62,900 (24/07/26), FPT trades at just 10.4x 2026F P/E versus a 5-year median above 18x, implying a 46% expected return (BUY). Risks: soft US/global IT spending, tariff-related deal delays, and JPY/USD FX swings.</a:t>
+              <a:t>We forecast FY26F NPATMI of VND 10,884bn (+15.0% YoY), FY27F VND 12,625bn (+16.0% YoY) and FY28F VND 14,582bn (+15.5% YoY), driven by a Global IT growth reacceleration (FY27F: +16.7%). Our DCF (FCFF)-based target price is VND 91,570; at the current two-year-low price of VND 62,900 (24/07/26), FPT trades at just 10.5x 2026F P/E versus a 5-year median above 18x, implying a 46% expected return (BUY). Risks: soft US/global IT spending, tariff-related deal delays, and JPY/USD FX swings.</a:t>
             </a:r>
           </a:p>
           <a:p>
@@ -30519,7 +30519,7 @@
                           <a:effectLst/>
                           <a:latin typeface="Noto Sans" panose="020B0502040504020204" pitchFamily="34" charset="0"/>
                         </a:rPr>
-                        <a:t>57,195</a:t>
+                        <a:t>57,165</a:t>
                       </a:r>
                     </a:p>
                   </a:txBody>
@@ -30572,7 +30572,7 @@
                           <a:effectLst/>
                           <a:latin typeface="Noto Sans" panose="020B0502040504020204" pitchFamily="34" charset="0"/>
                         </a:rPr>
-                        <a:t>65,945</a:t>
+                        <a:t>65,914</a:t>
                       </a:r>
                     </a:p>
                   </a:txBody>
@@ -30622,7 +30622,7 @@
                           <a:effectLst/>
                           <a:latin typeface="Noto Sans" panose="020B0502040504020204" pitchFamily="34" charset="0"/>
                         </a:rPr>
-                        <a:t>76,537</a:t>
+                        <a:t>76,504</a:t>
                       </a:r>
                     </a:p>
                   </a:txBody>
@@ -30851,7 +30851,7 @@
                           <a:effectLst/>
                           <a:latin typeface="Noto Sans" panose="020B0502040504020204" pitchFamily="34" charset="0"/>
                         </a:rPr>
-                        <a:t>9,757</a:t>
+                        <a:t>9,741</a:t>
                       </a:r>
                     </a:p>
                   </a:txBody>
@@ -30897,7 +30897,7 @@
                           <a:effectLst/>
                           <a:latin typeface="Noto Sans" panose="020B0502040504020204" pitchFamily="34" charset="0"/>
                         </a:rPr>
-                        <a:t>10,802</a:t>
+                        <a:t>10,785</a:t>
                       </a:r>
                     </a:p>
                   </a:txBody>
@@ -30940,7 +30940,7 @@
                           <a:effectLst/>
                           <a:latin typeface="Noto Sans" panose="020B0502040504020204" pitchFamily="34" charset="0"/>
                         </a:rPr>
-                        <a:t>12,260</a:t>
+                        <a:t>12,242</a:t>
                       </a:r>
                     </a:p>
                   </a:txBody>
@@ -31177,7 +31177,7 @@
                           <a:effectLst/>
                           <a:latin typeface="Noto Sans" panose="020B0502040504020204" pitchFamily="34" charset="0"/>
                         </a:rPr>
-                        <a:t>13,016</a:t>
+                        <a:t>12,998</a:t>
                       </a:r>
                     </a:p>
                   </a:txBody>
@@ -31226,7 +31226,7 @@
                           <a:effectLst/>
                           <a:latin typeface="Noto Sans" panose="020B0502040504020204" pitchFamily="34" charset="0"/>
                         </a:rPr>
-                        <a:t>15,121</a:t>
+                        <a:t>15,101</a:t>
                       </a:r>
                     </a:p>
                   </a:txBody>
@@ -31272,7 +31272,7 @@
                           <a:effectLst/>
                           <a:latin typeface="Noto Sans" panose="020B0502040504020204" pitchFamily="34" charset="0"/>
                         </a:rPr>
-                        <a:t>17,015</a:t>
+                        <a:t>17,441</a:t>
                       </a:r>
                     </a:p>
                   </a:txBody>
@@ -31509,7 +31509,7 @@
                           <a:effectLst/>
                           <a:latin typeface="Noto Sans" panose="020B0502040504020204" pitchFamily="34" charset="0"/>
                         </a:rPr>
-                        <a:t>10,898</a:t>
+                        <a:t>10,884</a:t>
                       </a:r>
                     </a:p>
                   </a:txBody>
@@ -31558,7 +31558,7 @@
                           <a:effectLst/>
                           <a:latin typeface="Noto Sans" panose="020B0502040504020204" pitchFamily="34" charset="0"/>
                         </a:rPr>
-                        <a:t>12,642</a:t>
+                        <a:t>12,625</a:t>
                       </a:r>
                     </a:p>
                   </a:txBody>
@@ -31604,7 +31604,7 @@
                           <a:effectLst/>
                           <a:latin typeface="Noto Sans" panose="020B0502040504020204" pitchFamily="34" charset="0"/>
                         </a:rPr>
-                        <a:t>14,225</a:t>
+                        <a:t>14,582</a:t>
                       </a:r>
                     </a:p>
                   </a:txBody>
@@ -31841,7 +31841,7 @@
                           <a:effectLst/>
                           <a:latin typeface="Noto Sans" panose="020B0502040504020204" pitchFamily="34" charset="0"/>
                         </a:rPr>
-                        <a:t>6,021</a:t>
+                        <a:t>6,013</a:t>
                       </a:r>
                     </a:p>
                   </a:txBody>
@@ -31890,7 +31890,7 @@
                           <a:effectLst/>
                           <a:latin typeface="Noto Sans" panose="020B0502040504020204" pitchFamily="34" charset="0"/>
                         </a:rPr>
-                        <a:t>6,984</a:t>
+                        <a:t>6,975</a:t>
                       </a:r>
                     </a:p>
                   </a:txBody>
@@ -31936,7 +31936,7 @@
                           <a:effectLst/>
                           <a:latin typeface="Noto Sans" panose="020B0502040504020204" pitchFamily="34" charset="0"/>
                         </a:rPr>
-                        <a:t>7,859</a:t>
+                        <a:t>8,056</a:t>
                       </a:r>
                     </a:p>
                   </a:txBody>
@@ -32268,7 +32268,7 @@
                           <a:effectLst/>
                           <a:latin typeface="Noto Sans" panose="020B0502040504020204" pitchFamily="34" charset="0"/>
                         </a:rPr>
-                        <a:t>25.7</a:t>
+                        <a:t>26.3</a:t>
                       </a:r>
                     </a:p>
                   </a:txBody>
@@ -32600,7 +32600,7 @@
                           <a:effectLst/>
                           <a:latin typeface="Noto Sans" panose="020B0502040504020204" pitchFamily="34" charset="0"/>
                         </a:rPr>
-                        <a:t>11.7</a:t>
+                        <a:t>11.4</a:t>
                       </a:r>
                     </a:p>
                   </a:txBody>
@@ -33185,7 +33185,7 @@
                           <a:effectLst/>
                           <a:latin typeface="Noto Sans" panose="020B0502040504020204" pitchFamily="34" charset="0"/>
                         </a:rPr>
-                        <a:t>91,894</a:t>
+                        <a:t>91,879</a:t>
                       </a:r>
                     </a:p>
                   </a:txBody>
@@ -33238,7 +33238,7 @@
                           <a:effectLst/>
                           <a:latin typeface="Noto Sans" panose="020B0502040504020204" pitchFamily="34" charset="0"/>
                         </a:rPr>
-                        <a:t>102,871</a:t>
+                        <a:t>102,839</a:t>
                       </a:r>
                     </a:p>
                   </a:txBody>
@@ -33288,7 +33288,7 @@
                           <a:effectLst/>
                           <a:latin typeface="Noto Sans" panose="020B0502040504020204" pitchFamily="34" charset="0"/>
                         </a:rPr>
-                        <a:t>115,272</a:t>
+                        <a:t>115,602</a:t>
                       </a:r>
                     </a:p>
                   </a:txBody>
@@ -33551,7 +33551,7 @@
                           <a:effectLst/>
                           <a:latin typeface="Noto Sans" panose="020B0502040504020204" pitchFamily="34" charset="0"/>
                         </a:rPr>
-                        <a:t>50,111</a:t>
+                        <a:t>50,096</a:t>
                       </a:r>
                     </a:p>
                   </a:txBody>
@@ -33604,7 +33604,7 @@
                           <a:effectLst/>
                           <a:latin typeface="Noto Sans" panose="020B0502040504020204" pitchFamily="34" charset="0"/>
                         </a:rPr>
-                        <a:t>58,225</a:t>
+                        <a:t>58,193</a:t>
                       </a:r>
                     </a:p>
                   </a:txBody>
@@ -33654,7 +33654,7 @@
                           <a:effectLst/>
                           <a:latin typeface="Noto Sans" panose="020B0502040504020204" pitchFamily="34" charset="0"/>
                         </a:rPr>
-                        <a:t>67,850</a:t>
+                        <a:t>68,181</a:t>
                       </a:r>
                     </a:p>
                   </a:txBody>
@@ -33911,7 +33911,7 @@
                           <a:effectLst/>
                           <a:latin typeface="Noto Sans" panose="020B0502040504020204" pitchFamily="34" charset="0"/>
                         </a:rPr>
-                        <a:t>25,082</a:t>
+                        <a:t>25,074</a:t>
                       </a:r>
                     </a:p>
                   </a:txBody>
@@ -33964,7 +33964,7 @@
                           <a:effectLst/>
                           <a:latin typeface="Noto Sans" panose="020B0502040504020204" pitchFamily="34" charset="0"/>
                         </a:rPr>
-                        <a:t>29,728</a:t>
+                        <a:t>29,709</a:t>
                       </a:r>
                     </a:p>
                   </a:txBody>
@@ -34014,7 +34014,7 @@
                           <a:effectLst/>
                           <a:latin typeface="Noto Sans" panose="020B0502040504020204" pitchFamily="34" charset="0"/>
                         </a:rPr>
-                        <a:t>35,245</a:t>
+                        <a:t>35,440</a:t>
                       </a:r>
                     </a:p>
                   </a:txBody>
@@ -35487,7 +35487,7 @@
                           <a:ea typeface="Noto Sans" panose="020B0502040504020204" pitchFamily="34" charset="0"/>
                           <a:cs typeface="Noto Sans" panose="020B0502040504020204" pitchFamily="34" charset="0"/>
                         </a:rPr>
-                        <a:t>10,898</a:t>
+                        <a:t>10,884</a:t>
                       </a:r>
                     </a:p>
                   </a:txBody>
@@ -35844,7 +35844,7 @@
                           <a:ea typeface="Noto Sans" panose="020B0502040504020204" pitchFamily="34" charset="0"/>
                           <a:cs typeface="Noto Sans" panose="020B0502040504020204" pitchFamily="34" charset="0"/>
                         </a:rPr>
-                        <a:t>18.7</a:t>
+                        <a:t>18.5</a:t>
                       </a:r>
                     </a:p>
                   </a:txBody>
@@ -38046,7 +38046,7 @@
                 <a:ea typeface="Noto Sans" panose="020B0502040504020204" pitchFamily="34" charset="0"/>
                 <a:cs typeface="Noto Sans" panose="020B0502040504020204" pitchFamily="34" charset="0"/>
               </a:rPr>
-              <a:t>Từ FY26, FPT Telecom được hạch toán theo phương pháp vốn chủ sở hữu (số liệu 2025 được điều chỉnh lại để so sánh). Doanh thu báo cáo do đó giảm về 57,195 tỷ đồng cho FY26F, trong khi lợi nhuận từ công ty liên kết (~2.9 nghìn tỷ FY26F) ghi nhận qua dòng liên doanh liên kết — giúp biên LN ròng tăng lên ~19% và giảm lợi ích cổ đông thiểu số, nhờ đó EPS tăng nhanh hơn LNST-CĐTS (FY26F: +18.7% so với +15.2%).</a:t>
+              <a:t>Từ FY26, FPT Telecom được hạch toán theo phương pháp vốn chủ sở hữu (số liệu 2025 được điều chỉnh lại để so sánh). Doanh thu báo cáo do đó giảm về 57,195 tỷ đồng cho FY26F, trong khi lợi nhuận từ công ty liên kết (~2.9 nghìn tỷ FY26F) ghi nhận qua dòng liên doanh liên kết — giúp biên LN ròng tăng lên ~19% và giảm lợi ích cổ đông thiểu số, nhờ đó EPS tăng nhanh hơn LNST-CĐTS (FY26F: +18.5% so với +15.0%).</a:t>
             </a:r>
           </a:p>
           <a:p>
@@ -38083,7 +38083,7 @@
                 <a:ea typeface="Noto Sans" panose="020B0502040504020204" pitchFamily="34" charset="0"/>
                 <a:cs typeface="Noto Sans" panose="020B0502040504020204" pitchFamily="34" charset="0"/>
               </a:rPr>
-              <a:t>Chúng tôi dự phóng LNST-CĐTS FY26F đạt 10,898 tỷ đồng (+15.2% CK) và FY27F đạt 12,642 tỷ đồng (+16.0% CK), dẫn dắt bởi đà tăng tốc trở lại của CNTT nước ngoài (FY27F: +16.7%). Giá mục tiêu theo DCF (FCFF) là 91,570 đồng/cp; tại thị giá đáy 2 năm 62,900 đồng (24/07/26), FPT giao dịch ở mức 10.4x P/E 2026F so với trung vị 5 năm trên 18x, tương ứng lợi nhuận kỳ vọng 46% (MUA). Rủi ro: chi tiêu CNTT tại Mỹ/toàn cầu suy yếu, trì hoãn hợp đồng do thuế quan, biến động tỷ giá JPY/USD.</a:t>
+              <a:t>Chúng tôi dự phóng LNST-CĐTS FY26F đạt 10,884 tỷ đồng (+15.0% CK), FY27F đạt 12,625 tỷ đồng (+16.0% CK) và FY28F đạt 14,582 tỷ đồng (+15.5% CK), dẫn dắt bởi đà tăng tốc trở lại của CNTT nước ngoài (FY27F: +16.7%). Giá mục tiêu theo DCF (FCFF) là 91,570 đồng/cp; tại thị giá đáy 2 năm 62,900 đồng (24/07/26), FPT giao dịch ở mức 10.5x P/E 2026F so với trung vị 5 năm trên 18x, tương ứng lợi nhuận kỳ vọng 46% (MUA). Rủi ro: chi tiêu CNTT tại Mỹ/toàn cầu suy yếu, trì hoãn hợp đồng do thuế quan, biến động tỷ giá JPY/USD.</a:t>
             </a:r>
             <a:endParaRPr kumimoji="1" lang="en-US" altLang="ko-KR" sz="800" b="0" dirty="0">
               <a:solidFill>
@@ -38810,7 +38810,7 @@
                           <a:effectLst/>
                           <a:latin typeface="Noto Sans" panose="020B0502040504020204" pitchFamily="34" charset="0"/>
                         </a:rPr>
-                        <a:t>57,195</a:t>
+                        <a:t>57,165</a:t>
                       </a:r>
                     </a:p>
                   </a:txBody>
@@ -38863,7 +38863,7 @@
                           <a:effectLst/>
                           <a:latin typeface="Noto Sans" panose="020B0502040504020204" pitchFamily="34" charset="0"/>
                         </a:rPr>
-                        <a:t>65,945</a:t>
+                        <a:t>65,914</a:t>
                       </a:r>
                     </a:p>
                   </a:txBody>
@@ -38913,7 +38913,7 @@
                           <a:effectLst/>
                           <a:latin typeface="Noto Sans" panose="020B0502040504020204" pitchFamily="34" charset="0"/>
                         </a:rPr>
-                        <a:t>76,537</a:t>
+                        <a:t>76,504</a:t>
                       </a:r>
                     </a:p>
                   </a:txBody>
@@ -39142,7 +39142,7 @@
                           <a:effectLst/>
                           <a:latin typeface="Noto Sans" panose="020B0502040504020204" pitchFamily="34" charset="0"/>
                         </a:rPr>
-                        <a:t>9,757</a:t>
+                        <a:t>9,741</a:t>
                       </a:r>
                     </a:p>
                   </a:txBody>
@@ -39188,7 +39188,7 @@
                           <a:effectLst/>
                           <a:latin typeface="Noto Sans" panose="020B0502040504020204" pitchFamily="34" charset="0"/>
                         </a:rPr>
-                        <a:t>10,802</a:t>
+                        <a:t>10,785</a:t>
                       </a:r>
                     </a:p>
                   </a:txBody>
@@ -39231,7 +39231,7 @@
                           <a:effectLst/>
                           <a:latin typeface="Noto Sans" panose="020B0502040504020204" pitchFamily="34" charset="0"/>
                         </a:rPr>
-                        <a:t>12,260</a:t>
+                        <a:t>12,242</a:t>
                       </a:r>
                     </a:p>
                   </a:txBody>
@@ -39468,7 +39468,7 @@
                           <a:effectLst/>
                           <a:latin typeface="Noto Sans" panose="020B0502040504020204" pitchFamily="34" charset="0"/>
                         </a:rPr>
-                        <a:t>13,016</a:t>
+                        <a:t>12,998</a:t>
                       </a:r>
                     </a:p>
                   </a:txBody>
@@ -39517,7 +39517,7 @@
                           <a:effectLst/>
                           <a:latin typeface="Noto Sans" panose="020B0502040504020204" pitchFamily="34" charset="0"/>
                         </a:rPr>
-                        <a:t>15,121</a:t>
+                        <a:t>15,101</a:t>
                       </a:r>
                     </a:p>
                   </a:txBody>
@@ -39563,7 +39563,7 @@
                           <a:effectLst/>
                           <a:latin typeface="Noto Sans" panose="020B0502040504020204" pitchFamily="34" charset="0"/>
                         </a:rPr>
-                        <a:t>17,015</a:t>
+                        <a:t>17,441</a:t>
                       </a:r>
                     </a:p>
                   </a:txBody>
@@ -39800,7 +39800,7 @@
                           <a:effectLst/>
                           <a:latin typeface="Noto Sans" panose="020B0502040504020204" pitchFamily="34" charset="0"/>
                         </a:rPr>
-                        <a:t>10,898</a:t>
+                        <a:t>10,884</a:t>
                       </a:r>
                     </a:p>
                   </a:txBody>
@@ -39849,7 +39849,7 @@
                           <a:effectLst/>
                           <a:latin typeface="Noto Sans" panose="020B0502040504020204" pitchFamily="34" charset="0"/>
                         </a:rPr>
-                        <a:t>12,642</a:t>
+                        <a:t>12,625</a:t>
                       </a:r>
                     </a:p>
                   </a:txBody>
@@ -39895,7 +39895,7 @@
                           <a:effectLst/>
                           <a:latin typeface="Noto Sans" panose="020B0502040504020204" pitchFamily="34" charset="0"/>
                         </a:rPr>
-                        <a:t>14,225</a:t>
+                        <a:t>14,582</a:t>
                       </a:r>
                     </a:p>
                   </a:txBody>
@@ -40132,7 +40132,7 @@
                           <a:effectLst/>
                           <a:latin typeface="Noto Sans" panose="020B0502040504020204" pitchFamily="34" charset="0"/>
                         </a:rPr>
-                        <a:t>6,021</a:t>
+                        <a:t>6,013</a:t>
                       </a:r>
                     </a:p>
                   </a:txBody>
@@ -40181,7 +40181,7 @@
                           <a:effectLst/>
                           <a:latin typeface="Noto Sans" panose="020B0502040504020204" pitchFamily="34" charset="0"/>
                         </a:rPr>
-                        <a:t>6,984</a:t>
+                        <a:t>6,975</a:t>
                       </a:r>
                     </a:p>
                   </a:txBody>
@@ -40227,7 +40227,7 @@
                           <a:effectLst/>
                           <a:latin typeface="Noto Sans" panose="020B0502040504020204" pitchFamily="34" charset="0"/>
                         </a:rPr>
-                        <a:t>7,859</a:t>
+                        <a:t>8,056</a:t>
                       </a:r>
                     </a:p>
                   </a:txBody>
@@ -40559,7 +40559,7 @@
                           <a:effectLst/>
                           <a:latin typeface="Noto Sans" panose="020B0502040504020204" pitchFamily="34" charset="0"/>
                         </a:rPr>
-                        <a:t>25.7</a:t>
+                        <a:t>26.3</a:t>
                       </a:r>
                     </a:p>
                   </a:txBody>
@@ -40891,7 +40891,7 @@
                           <a:effectLst/>
                           <a:latin typeface="Noto Sans" panose="020B0502040504020204" pitchFamily="34" charset="0"/>
                         </a:rPr>
-                        <a:t>11.7</a:t>
+                        <a:t>11.4</a:t>
                       </a:r>
                     </a:p>
                   </a:txBody>
@@ -41485,7 +41485,7 @@
                           <a:effectLst/>
                           <a:latin typeface="Noto Sans" panose="020B0502040504020204" pitchFamily="34" charset="0"/>
                         </a:rPr>
-                        <a:t>91,894</a:t>
+                        <a:t>91,879</a:t>
                       </a:r>
                     </a:p>
                   </a:txBody>
@@ -41538,7 +41538,7 @@
                           <a:effectLst/>
                           <a:latin typeface="Noto Sans" panose="020B0502040504020204" pitchFamily="34" charset="0"/>
                         </a:rPr>
-                        <a:t>102,871</a:t>
+                        <a:t>102,839</a:t>
                       </a:r>
                     </a:p>
                   </a:txBody>
@@ -41588,7 +41588,7 @@
                           <a:effectLst/>
                           <a:latin typeface="Noto Sans" panose="020B0502040504020204" pitchFamily="34" charset="0"/>
                         </a:rPr>
-                        <a:t>115,272</a:t>
+                        <a:t>115,602</a:t>
                       </a:r>
                     </a:p>
                   </a:txBody>
@@ -41854,7 +41854,7 @@
                           <a:effectLst/>
                           <a:latin typeface="Noto Sans" panose="020B0502040504020204" pitchFamily="34" charset="0"/>
                         </a:rPr>
-                        <a:t>50,111</a:t>
+                        <a:t>50,096</a:t>
                       </a:r>
                     </a:p>
                   </a:txBody>
@@ -41907,7 +41907,7 @@
                           <a:effectLst/>
                           <a:latin typeface="Noto Sans" panose="020B0502040504020204" pitchFamily="34" charset="0"/>
                         </a:rPr>
-                        <a:t>58,225</a:t>
+                        <a:t>58,193</a:t>
                       </a:r>
                     </a:p>
                   </a:txBody>
@@ -41957,7 +41957,7 @@
                           <a:effectLst/>
                           <a:latin typeface="Noto Sans" panose="020B0502040504020204" pitchFamily="34" charset="0"/>
                         </a:rPr>
-                        <a:t>67,850</a:t>
+                        <a:t>68,181</a:t>
                       </a:r>
                     </a:p>
                   </a:txBody>
@@ -42214,7 +42214,7 @@
                           <a:effectLst/>
                           <a:latin typeface="Noto Sans" panose="020B0502040504020204" pitchFamily="34" charset="0"/>
                         </a:rPr>
-                        <a:t>25,082</a:t>
+                        <a:t>25,074</a:t>
                       </a:r>
                     </a:p>
                   </a:txBody>
@@ -42267,7 +42267,7 @@
                           <a:effectLst/>
                           <a:latin typeface="Noto Sans" panose="020B0502040504020204" pitchFamily="34" charset="0"/>
                         </a:rPr>
-                        <a:t>29,728</a:t>
+                        <a:t>29,709</a:t>
                       </a:r>
                     </a:p>
                   </a:txBody>
@@ -42317,7 +42317,7 @@
                           <a:effectLst/>
                           <a:latin typeface="Noto Sans" panose="020B0502040504020204" pitchFamily="34" charset="0"/>
                         </a:rPr>
-                        <a:t>35,245</a:t>
+                        <a:t>35,440</a:t>
                       </a:r>
                     </a:p>
                   </a:txBody>

</xml_diff>

<commit_message>
Reweight FPT growth path: FY27F +15.5%, FY28F +16.0%
Analyst call to swap the FY27/FY28 growth split. Because 1.155*1.16 =
1.16*1.155, the FY28F NPATMI level is unchanged (14,582) - only FY27F
moves, so this is a single-cell edit: Scenarios!I45 4.857% -> 4.758%.
FY27F NPATMI 12,625 -> 12,571; EPS 6,975 -> 6,945. Cascaded to deck FY
table and narrative (EN+VN) and the stock-pick FPT row.

Trajectory now +15.0% / +15.5% / +16.0% (accelerating).

Co-Authored-By: Claude Fable 5 <noreply@anthropic.com>
Claude-Session: https://claude.ai/code/session_01QPsxWfyBSmSQjUzo5EDnm5
</commit_message>
<xml_diff>
--- a/MASVN_RS_WM_2H26_outlook_Equity_VN_2026_STBFPT_24July2026.pptx
+++ b/MASVN_RS_WM_2H26_outlook_Equity_VN_2026_STBFPT_24July2026.pptx
@@ -29771,7 +29771,7 @@
                 <a:ea typeface="Noto Sans" panose="020B0502040504020204" pitchFamily="34" charset="0"/>
                 <a:cs typeface="Noto Sans" panose="020B0502040504020204" pitchFamily="34" charset="0"/>
               </a:rPr>
-              <a:t>We forecast FY26F NPATMI of VND 10,884bn (+15.0% YoY), FY27F VND 12,625bn (+16.0% YoY) and FY28F VND 14,582bn (+15.5% YoY), driven by a Global IT growth reacceleration (FY27F: +16.7%). Our DCF (FCFF)-based target price is VND 91,570; at the current two-year-low price of VND 62,900 (24/07/26), FPT trades at just 10.5x 2026F P/E versus a 5-year median above 18x, implying a 46% expected return (BUY). Risks: soft US/global IT spending, tariff-related deal delays, and JPY/USD FX swings.</a:t>
+              <a:t>We forecast FY26F NPATMI of VND 10,884bn (+15.0% YoY), FY27F VND 12,571bn (+15.5% YoY) and FY28F VND 14,582bn (+16.0% YoY), driven by a Global IT growth reacceleration (FY27F: +16.7%). Our DCF (FCFF)-based target price is VND 91,570; at the current two-year-low price of VND 62,900 (24/07/26), FPT trades at just 10.5x 2026F P/E versus a 5-year median above 18x, implying a 46% expected return (BUY). Risks: soft US/global IT spending, tariff-related deal delays, and JPY/USD FX swings.</a:t>
             </a:r>
           </a:p>
           <a:p>
@@ -31226,7 +31226,7 @@
                           <a:effectLst/>
                           <a:latin typeface="Noto Sans" panose="020B0502040504020204" pitchFamily="34" charset="0"/>
                         </a:rPr>
-                        <a:t>15,101</a:t>
+                        <a:t>15,036</a:t>
                       </a:r>
                     </a:p>
                   </a:txBody>
@@ -31558,7 +31558,7 @@
                           <a:effectLst/>
                           <a:latin typeface="Noto Sans" panose="020B0502040504020204" pitchFamily="34" charset="0"/>
                         </a:rPr>
-                        <a:t>12,625</a:t>
+                        <a:t>12,571</a:t>
                       </a:r>
                     </a:p>
                   </a:txBody>
@@ -31890,7 +31890,7 @@
                           <a:effectLst/>
                           <a:latin typeface="Noto Sans" panose="020B0502040504020204" pitchFamily="34" charset="0"/>
                         </a:rPr>
-                        <a:t>6,975</a:t>
+                        <a:t>6,945</a:t>
                       </a:r>
                     </a:p>
                   </a:txBody>
@@ -32222,7 +32222,7 @@
                           <a:effectLst/>
                           <a:latin typeface="Noto Sans" panose="020B0502040504020204" pitchFamily="34" charset="0"/>
                         </a:rPr>
-                        <a:t>27.0</a:t>
+                        <a:t>26.8</a:t>
                       </a:r>
                     </a:p>
                   </a:txBody>
@@ -32554,7 +32554,7 @@
                           <a:effectLst/>
                           <a:latin typeface="Noto Sans" panose="020B0502040504020204" pitchFamily="34" charset="0"/>
                         </a:rPr>
-                        <a:t>13.1</a:t>
+                        <a:t>13.2</a:t>
                       </a:r>
                     </a:p>
                   </a:txBody>
@@ -33238,7 +33238,7 @@
                           <a:effectLst/>
                           <a:latin typeface="Noto Sans" panose="020B0502040504020204" pitchFamily="34" charset="0"/>
                         </a:rPr>
-                        <a:t>102,839</a:t>
+                        <a:t>102,783</a:t>
                       </a:r>
                     </a:p>
                   </a:txBody>
@@ -33288,7 +33288,7 @@
                           <a:effectLst/>
                           <a:latin typeface="Noto Sans" panose="020B0502040504020204" pitchFamily="34" charset="0"/>
                         </a:rPr>
-                        <a:t>115,602</a:t>
+                        <a:t>115,547</a:t>
                       </a:r>
                     </a:p>
                   </a:txBody>
@@ -33604,7 +33604,7 @@
                           <a:effectLst/>
                           <a:latin typeface="Noto Sans" panose="020B0502040504020204" pitchFamily="34" charset="0"/>
                         </a:rPr>
-                        <a:t>58,193</a:t>
+                        <a:t>58,138</a:t>
                       </a:r>
                     </a:p>
                   </a:txBody>
@@ -33654,7 +33654,7 @@
                           <a:effectLst/>
                           <a:latin typeface="Noto Sans" panose="020B0502040504020204" pitchFamily="34" charset="0"/>
                         </a:rPr>
-                        <a:t>68,181</a:t>
+                        <a:t>68,126</a:t>
                       </a:r>
                     </a:p>
                   </a:txBody>
@@ -33964,7 +33964,7 @@
                           <a:effectLst/>
                           <a:latin typeface="Noto Sans" panose="020B0502040504020204" pitchFamily="34" charset="0"/>
                         </a:rPr>
-                        <a:t>29,709</a:t>
+                        <a:t>29,677</a:t>
                       </a:r>
                     </a:p>
                   </a:txBody>
@@ -34014,7 +34014,7 @@
                           <a:effectLst/>
                           <a:latin typeface="Noto Sans" panose="020B0502040504020204" pitchFamily="34" charset="0"/>
                         </a:rPr>
-                        <a:t>35,440</a:t>
+                        <a:t>35,407</a:t>
                       </a:r>
                     </a:p>
                   </a:txBody>
@@ -38083,7 +38083,7 @@
                 <a:ea typeface="Noto Sans" panose="020B0502040504020204" pitchFamily="34" charset="0"/>
                 <a:cs typeface="Noto Sans" panose="020B0502040504020204" pitchFamily="34" charset="0"/>
               </a:rPr>
-              <a:t>Chúng tôi dự phóng LNST-CĐTS FY26F đạt 10,884 tỷ đồng (+15.0% CK), FY27F đạt 12,625 tỷ đồng (+16.0% CK) và FY28F đạt 14,582 tỷ đồng (+15.5% CK), dẫn dắt bởi đà tăng tốc trở lại của CNTT nước ngoài (FY27F: +16.7%). Giá mục tiêu theo DCF (FCFF) là 91,570 đồng/cp; tại thị giá đáy 2 năm 62,900 đồng (24/07/26), FPT giao dịch ở mức 10.5x P/E 2026F so với trung vị 5 năm trên 18x, tương ứng lợi nhuận kỳ vọng 46% (MUA). Rủi ro: chi tiêu CNTT tại Mỹ/toàn cầu suy yếu, trì hoãn hợp đồng do thuế quan, biến động tỷ giá JPY/USD.</a:t>
+              <a:t>Chúng tôi dự phóng LNST-CĐTS FY26F đạt 10,884 tỷ đồng (+15.0% CK), FY27F đạt 12,571 tỷ đồng (+15.5% CK) và FY28F đạt 14,582 tỷ đồng (+16.0% CK), dẫn dắt bởi đà tăng tốc trở lại của CNTT nước ngoài (FY27F: +16.7%). Giá mục tiêu theo DCF (FCFF) là 91,570 đồng/cp; tại thị giá đáy 2 năm 62,900 đồng (24/07/26), FPT giao dịch ở mức 10.5x P/E 2026F so với trung vị 5 năm trên 18x, tương ứng lợi nhuận kỳ vọng 46% (MUA). Rủi ro: chi tiêu CNTT tại Mỹ/toàn cầu suy yếu, trì hoãn hợp đồng do thuế quan, biến động tỷ giá JPY/USD.</a:t>
             </a:r>
             <a:endParaRPr kumimoji="1" lang="en-US" altLang="ko-KR" sz="800" b="0" dirty="0">
               <a:solidFill>
@@ -39517,7 +39517,7 @@
                           <a:effectLst/>
                           <a:latin typeface="Noto Sans" panose="020B0502040504020204" pitchFamily="34" charset="0"/>
                         </a:rPr>
-                        <a:t>15,101</a:t>
+                        <a:t>15,036</a:t>
                       </a:r>
                     </a:p>
                   </a:txBody>
@@ -39849,7 +39849,7 @@
                           <a:effectLst/>
                           <a:latin typeface="Noto Sans" panose="020B0502040504020204" pitchFamily="34" charset="0"/>
                         </a:rPr>
-                        <a:t>12,625</a:t>
+                        <a:t>12,571</a:t>
                       </a:r>
                     </a:p>
                   </a:txBody>
@@ -40181,7 +40181,7 @@
                           <a:effectLst/>
                           <a:latin typeface="Noto Sans" panose="020B0502040504020204" pitchFamily="34" charset="0"/>
                         </a:rPr>
-                        <a:t>6,975</a:t>
+                        <a:t>6,945</a:t>
                       </a:r>
                     </a:p>
                   </a:txBody>
@@ -40513,7 +40513,7 @@
                           <a:effectLst/>
                           <a:latin typeface="Noto Sans" panose="020B0502040504020204" pitchFamily="34" charset="0"/>
                         </a:rPr>
-                        <a:t>27.0</a:t>
+                        <a:t>26.8</a:t>
                       </a:r>
                     </a:p>
                   </a:txBody>
@@ -40845,7 +40845,7 @@
                           <a:effectLst/>
                           <a:latin typeface="Noto Sans" panose="020B0502040504020204" pitchFamily="34" charset="0"/>
                         </a:rPr>
-                        <a:t>13.1</a:t>
+                        <a:t>13.2</a:t>
                       </a:r>
                     </a:p>
                   </a:txBody>
@@ -41538,7 +41538,7 @@
                           <a:effectLst/>
                           <a:latin typeface="Noto Sans" panose="020B0502040504020204" pitchFamily="34" charset="0"/>
                         </a:rPr>
-                        <a:t>102,839</a:t>
+                        <a:t>102,783</a:t>
                       </a:r>
                     </a:p>
                   </a:txBody>
@@ -41588,7 +41588,7 @@
                           <a:effectLst/>
                           <a:latin typeface="Noto Sans" panose="020B0502040504020204" pitchFamily="34" charset="0"/>
                         </a:rPr>
-                        <a:t>115,602</a:t>
+                        <a:t>115,547</a:t>
                       </a:r>
                     </a:p>
                   </a:txBody>
@@ -41907,7 +41907,7 @@
                           <a:effectLst/>
                           <a:latin typeface="Noto Sans" panose="020B0502040504020204" pitchFamily="34" charset="0"/>
                         </a:rPr>
-                        <a:t>58,193</a:t>
+                        <a:t>58,138</a:t>
                       </a:r>
                     </a:p>
                   </a:txBody>
@@ -41957,7 +41957,7 @@
                           <a:effectLst/>
                           <a:latin typeface="Noto Sans" panose="020B0502040504020204" pitchFamily="34" charset="0"/>
                         </a:rPr>
-                        <a:t>68,181</a:t>
+                        <a:t>68,126</a:t>
                       </a:r>
                     </a:p>
                   </a:txBody>
@@ -42267,7 +42267,7 @@
                           <a:effectLst/>
                           <a:latin typeface="Noto Sans" panose="020B0502040504020204" pitchFamily="34" charset="0"/>
                         </a:rPr>
-                        <a:t>29,709</a:t>
+                        <a:t>29,677</a:t>
                       </a:r>
                     </a:p>
                   </a:txBody>
@@ -42317,7 +42317,7 @@
                           <a:effectLst/>
                           <a:latin typeface="Noto Sans" panose="020B0502040504020204" pitchFamily="34" charset="0"/>
                         </a:rPr>
-                        <a:t>35,440</a:t>
+                        <a:t>35,407</a:t>
                       </a:r>
                     </a:p>
                   </a:txBody>

</xml_diff>

<commit_message>
Set FPT Domestic IT FY26F to +14%, headcount held at 45,000
Analyst call: Domestic IT growth raised 12.69% -> 14.0% (Scenarios!H17),
lifting 2H26 implied growth from +6.7% to +8.8% so the forecast no
longer reads as government digitalization demand stopping mid-year.
Headcount deliberately left at 45,000, so the incremental revenue drops
through at high margin and FY26F NPATMI lands at +15.6% (10,943) rather
than +15.0%.

Telecom associate growth held at +15% p.a. (I45/J45 restruck on the new
revenue base); TP held at 78,750 by re-solving the Valuation ERP to
8.966% as the higher NPATMI also lifts FCFF. FY27F/FY28F NPATMI 12,518
/14,156 (+14.4%/+13.1%). Cascaded to deck and stock pick.

Co-Authored-By: Claude Fable 5 <noreply@anthropic.com>
Claude-Session: https://claude.ai/code/session_01QPsxWfyBSmSQjUzo5EDnm5
</commit_message>
<xml_diff>
--- a/MASVN_RS_WM_2H26_outlook_Equity_VN_2026_STBFPT_24July2026.pptx
+++ b/MASVN_RS_WM_2H26_outlook_Equity_VN_2026_STBFPT_24July2026.pptx
@@ -28155,7 +28155,7 @@
                           <a:ea typeface="Noto Sans" panose="020B0502040504020204" pitchFamily="34" charset="0"/>
                           <a:cs typeface="Noto Sans" panose="020B0502040504020204" pitchFamily="34" charset="0"/>
                         </a:rPr>
-                        <a:t>10,884</a:t>
+                        <a:t>10,943</a:t>
                       </a:r>
                     </a:p>
                   </a:txBody>
@@ -28320,7 +28320,7 @@
                           <a:ea typeface="Noto Sans" panose="020B0502040504020204" pitchFamily="34" charset="0"/>
                           <a:cs typeface="Noto Sans" panose="020B0502040504020204" pitchFamily="34" charset="0"/>
                         </a:rPr>
-                        <a:t>18.5</a:t>
+                        <a:t>19.2</a:t>
                       </a:r>
                     </a:p>
                   </a:txBody>
@@ -28404,7 +28404,7 @@
                           <a:ea typeface="Noto Sans" panose="020B0502040504020204" pitchFamily="34" charset="0"/>
                           <a:cs typeface="Noto Sans" panose="020B0502040504020204" pitchFamily="34" charset="0"/>
                         </a:rPr>
-                        <a:t>13.1</a:t>
+                        <a:t>13.0</a:t>
                       </a:r>
                     </a:p>
                   </a:txBody>
@@ -29771,7 +29771,7 @@
                 <a:ea typeface="Noto Sans" panose="020B0502040504020204" pitchFamily="34" charset="0"/>
                 <a:cs typeface="Noto Sans" panose="020B0502040504020204" pitchFamily="34" charset="0"/>
               </a:rPr>
-              <a:t>We forecast FY26F NPATMI of VND 10,884bn (+15.0% YoY), FY27F VND 12,451bn (+14.4% YoY) and FY28F VND 14,080bn (+13.1% YoY), with associate income from FPT Telecom assumed to grow ~15% p.a. Our DCF (FCFF)-based target price is VND 78,750; at the current price of VND 62,900 (24/07/26) FPT trades at 10.5x 2026F P/E versus a 5-year median above 18x, implying a 25% expected return (BUY). Risks: soft US/global IT spending, tariff-related deal delays, and JPY/USD FX swings.</a:t>
+              <a:t>We forecast FY26F NPATMI of VND 10,943bn (+15.6% YoY), FY27F VND 12,518bn (+14.4% YoY) and FY28F VND 14,156bn (+13.1% YoY), with associate income from FPT Telecom assumed to grow ~15% p.a. Our DCF (FCFF)-based target price is VND 78,750; at the current price of VND 62,900 (24/07/26) FPT trades at 10.4x 2026F P/E versus a 5-year median above 18x, implying a 25% expected return (BUY). Risks: soft US/global IT spending, tariff-related deal delays, and JPY/USD FX swings.</a:t>
             </a:r>
           </a:p>
           <a:p>
@@ -30519,7 +30519,7 @@
                           <a:effectLst/>
                           <a:latin typeface="Noto Sans" panose="020B0502040504020204" pitchFamily="34" charset="0"/>
                         </a:rPr>
-                        <a:t>57,165</a:t>
+                        <a:t>57,284</a:t>
                       </a:r>
                     </a:p>
                   </a:txBody>
@@ -30572,7 +30572,7 @@
                           <a:effectLst/>
                           <a:latin typeface="Noto Sans" panose="020B0502040504020204" pitchFamily="34" charset="0"/>
                         </a:rPr>
-                        <a:t>65,914</a:t>
+                        <a:t>66,048</a:t>
                       </a:r>
                     </a:p>
                   </a:txBody>
@@ -30622,7 +30622,7 @@
                           <a:effectLst/>
                           <a:latin typeface="Noto Sans" panose="020B0502040504020204" pitchFamily="34" charset="0"/>
                         </a:rPr>
-                        <a:t>76,504</a:t>
+                        <a:t>76,654</a:t>
                       </a:r>
                     </a:p>
                   </a:txBody>
@@ -30851,7 +30851,7 @@
                           <a:effectLst/>
                           <a:latin typeface="Noto Sans" panose="020B0502040504020204" pitchFamily="34" charset="0"/>
                         </a:rPr>
-                        <a:t>9,741</a:t>
+                        <a:t>9,807</a:t>
                       </a:r>
                     </a:p>
                   </a:txBody>
@@ -30897,7 +30897,7 @@
                           <a:effectLst/>
                           <a:latin typeface="Noto Sans" panose="020B0502040504020204" pitchFamily="34" charset="0"/>
                         </a:rPr>
-                        <a:t>10,785</a:t>
+                        <a:t>10,859</a:t>
                       </a:r>
                     </a:p>
                   </a:txBody>
@@ -30940,7 +30940,7 @@
                           <a:effectLst/>
                           <a:latin typeface="Noto Sans" panose="020B0502040504020204" pitchFamily="34" charset="0"/>
                         </a:rPr>
-                        <a:t>12,242</a:t>
+                        <a:t>12,325</a:t>
                       </a:r>
                     </a:p>
                   </a:txBody>
@@ -31177,7 +31177,7 @@
                           <a:effectLst/>
                           <a:latin typeface="Noto Sans" panose="020B0502040504020204" pitchFamily="34" charset="0"/>
                         </a:rPr>
-                        <a:t>12,998</a:t>
+                        <a:t>13,069</a:t>
                       </a:r>
                     </a:p>
                   </a:txBody>
@@ -31226,7 +31226,7 @@
                           <a:effectLst/>
                           <a:latin typeface="Noto Sans" panose="020B0502040504020204" pitchFamily="34" charset="0"/>
                         </a:rPr>
-                        <a:t>14,892</a:t>
+                        <a:t>14,973</a:t>
                       </a:r>
                     </a:p>
                   </a:txBody>
@@ -31272,7 +31272,7 @@
                           <a:effectLst/>
                           <a:latin typeface="Noto Sans" panose="020B0502040504020204" pitchFamily="34" charset="0"/>
                         </a:rPr>
-                        <a:t>16,841</a:t>
+                        <a:t>16,931</a:t>
                       </a:r>
                     </a:p>
                   </a:txBody>
@@ -31509,7 +31509,7 @@
                           <a:effectLst/>
                           <a:latin typeface="Noto Sans" panose="020B0502040504020204" pitchFamily="34" charset="0"/>
                         </a:rPr>
-                        <a:t>10,884</a:t>
+                        <a:t>10,943</a:t>
                       </a:r>
                     </a:p>
                   </a:txBody>
@@ -31558,7 +31558,7 @@
                           <a:effectLst/>
                           <a:latin typeface="Noto Sans" panose="020B0502040504020204" pitchFamily="34" charset="0"/>
                         </a:rPr>
-                        <a:t>12,451</a:t>
+                        <a:t>12,518</a:t>
                       </a:r>
                     </a:p>
                   </a:txBody>
@@ -31604,7 +31604,7 @@
                           <a:effectLst/>
                           <a:latin typeface="Noto Sans" panose="020B0502040504020204" pitchFamily="34" charset="0"/>
                         </a:rPr>
-                        <a:t>14,080</a:t>
+                        <a:t>14,156</a:t>
                       </a:r>
                     </a:p>
                   </a:txBody>
@@ -31841,7 +31841,7 @@
                           <a:effectLst/>
                           <a:latin typeface="Noto Sans" panose="020B0502040504020204" pitchFamily="34" charset="0"/>
                         </a:rPr>
-                        <a:t>6,013</a:t>
+                        <a:t>6,046</a:t>
                       </a:r>
                     </a:p>
                   </a:txBody>
@@ -31890,7 +31890,7 @@
                           <a:effectLst/>
                           <a:latin typeface="Noto Sans" panose="020B0502040504020204" pitchFamily="34" charset="0"/>
                         </a:rPr>
-                        <a:t>6,879</a:t>
+                        <a:t>6,916</a:t>
                       </a:r>
                     </a:p>
                   </a:txBody>
@@ -31936,7 +31936,7 @@
                           <a:effectLst/>
                           <a:latin typeface="Noto Sans" panose="020B0502040504020204" pitchFamily="34" charset="0"/>
                         </a:rPr>
-                        <a:t>7,779</a:t>
+                        <a:t>7,821</a:t>
                       </a:r>
                     </a:p>
                   </a:txBody>
@@ -32173,7 +32173,7 @@
                           <a:effectLst/>
                           <a:latin typeface="Noto Sans" panose="020B0502040504020204" pitchFamily="34" charset="0"/>
                         </a:rPr>
-                        <a:t>27.4</a:t>
+                        <a:t>27.5</a:t>
                       </a:r>
                     </a:p>
                   </a:txBody>
@@ -32222,7 +32222,7 @@
                           <a:effectLst/>
                           <a:latin typeface="Noto Sans" panose="020B0502040504020204" pitchFamily="34" charset="0"/>
                         </a:rPr>
-                        <a:t>26.6</a:t>
+                        <a:t>26.7</a:t>
                       </a:r>
                     </a:p>
                   </a:txBody>
@@ -32268,7 +32268,7 @@
                           <a:effectLst/>
                           <a:latin typeface="Noto Sans" panose="020B0502040504020204" pitchFamily="34" charset="0"/>
                         </a:rPr>
-                        <a:t>25.4</a:t>
+                        <a:t>25.6</a:t>
                       </a:r>
                     </a:p>
                   </a:txBody>
@@ -32505,7 +32505,7 @@
                           <a:effectLst/>
                           <a:latin typeface="Noto Sans" panose="020B0502040504020204" pitchFamily="34" charset="0"/>
                         </a:rPr>
-                        <a:t>13.1</a:t>
+                        <a:t>13.0</a:t>
                       </a:r>
                     </a:p>
                   </a:txBody>
@@ -33185,7 +33185,7 @@
                           <a:effectLst/>
                           <a:latin typeface="Noto Sans" panose="020B0502040504020204" pitchFamily="34" charset="0"/>
                         </a:rPr>
-                        <a:t>91,879</a:t>
+                        <a:t>91,940</a:t>
                       </a:r>
                     </a:p>
                   </a:txBody>
@@ -33238,7 +33238,7 @@
                           <a:effectLst/>
                           <a:latin typeface="Noto Sans" panose="020B0502040504020204" pitchFamily="34" charset="0"/>
                         </a:rPr>
-                        <a:t>102,661</a:t>
+                        <a:t>102,790</a:t>
                       </a:r>
                     </a:p>
                   </a:txBody>
@@ -33288,7 +33288,7 @@
                           <a:effectLst/>
                           <a:latin typeface="Noto Sans" panose="020B0502040504020204" pitchFamily="34" charset="0"/>
                         </a:rPr>
-                        <a:t>114,915</a:t>
+                        <a:t>115,120</a:t>
                       </a:r>
                     </a:p>
                   </a:txBody>
@@ -33551,7 +33551,7 @@
                           <a:effectLst/>
                           <a:latin typeface="Noto Sans" panose="020B0502040504020204" pitchFamily="34" charset="0"/>
                         </a:rPr>
-                        <a:t>50,096</a:t>
+                        <a:t>50,157</a:t>
                       </a:r>
                     </a:p>
                   </a:txBody>
@@ -33604,7 +33604,7 @@
                           <a:effectLst/>
                           <a:latin typeface="Noto Sans" panose="020B0502040504020204" pitchFamily="34" charset="0"/>
                         </a:rPr>
-                        <a:t>58,016</a:t>
+                        <a:t>58,145</a:t>
                       </a:r>
                     </a:p>
                   </a:txBody>
@@ -33654,7 +33654,7 @@
                           <a:effectLst/>
                           <a:latin typeface="Noto Sans" panose="020B0502040504020204" pitchFamily="34" charset="0"/>
                         </a:rPr>
-                        <a:t>67,493</a:t>
+                        <a:t>67,699</a:t>
                       </a:r>
                     </a:p>
                   </a:txBody>
@@ -33911,7 +33911,7 @@
                           <a:effectLst/>
                           <a:latin typeface="Noto Sans" panose="020B0502040504020204" pitchFamily="34" charset="0"/>
                         </a:rPr>
-                        <a:t>25,074</a:t>
+                        <a:t>25,109</a:t>
                       </a:r>
                     </a:p>
                   </a:txBody>
@@ -33964,7 +33964,7 @@
                           <a:effectLst/>
                           <a:latin typeface="Noto Sans" panose="020B0502040504020204" pitchFamily="34" charset="0"/>
                         </a:rPr>
-                        <a:t>29,605</a:t>
+                        <a:t>29,681</a:t>
                       </a:r>
                     </a:p>
                   </a:txBody>
@@ -34014,7 +34014,7 @@
                           <a:effectLst/>
                           <a:latin typeface="Noto Sans" panose="020B0502040504020204" pitchFamily="34" charset="0"/>
                         </a:rPr>
-                        <a:t>35,036</a:t>
+                        <a:t>35,157</a:t>
                       </a:r>
                     </a:p>
                   </a:txBody>
@@ -35487,7 +35487,7 @@
                           <a:ea typeface="Noto Sans" panose="020B0502040504020204" pitchFamily="34" charset="0"/>
                           <a:cs typeface="Noto Sans" panose="020B0502040504020204" pitchFamily="34" charset="0"/>
                         </a:rPr>
-                        <a:t>10,884</a:t>
+                        <a:t>10,943</a:t>
                       </a:r>
                     </a:p>
                   </a:txBody>
@@ -35844,7 +35844,7 @@
                           <a:ea typeface="Noto Sans" panose="020B0502040504020204" pitchFamily="34" charset="0"/>
                           <a:cs typeface="Noto Sans" panose="020B0502040504020204" pitchFamily="34" charset="0"/>
                         </a:rPr>
-                        <a:t>18.5</a:t>
+                        <a:t>19.2</a:t>
                       </a:r>
                     </a:p>
                   </a:txBody>
@@ -35928,7 +35928,7 @@
                           <a:ea typeface="Noto Sans" panose="020B0502040504020204" pitchFamily="34" charset="0"/>
                           <a:cs typeface="Noto Sans" panose="020B0502040504020204" pitchFamily="34" charset="0"/>
                         </a:rPr>
-                        <a:t>13.1</a:t>
+                        <a:t>13.0</a:t>
                       </a:r>
                     </a:p>
                   </a:txBody>
@@ -38083,7 +38083,7 @@
                 <a:ea typeface="Noto Sans" panose="020B0502040504020204" pitchFamily="34" charset="0"/>
                 <a:cs typeface="Noto Sans" panose="020B0502040504020204" pitchFamily="34" charset="0"/>
               </a:rPr>
-              <a:t>Chúng tôi dự phóng LNST-CĐTS FY26F đạt 10,884 tỷ đồng (+15.0% CK), FY27F đạt 12,451 tỷ đồng (+14.4% CK) và FY28F đạt 14,080 tỷ đồng (+13.1% CK), với giả định lợi nhuận từ FPT Telecom tăng ~15%/năm. Giá mục tiêu theo DCF (FCFF) là 78,750 đồng/cp; tại thị giá 62,900 đồng (24/07/26), FPT giao dịch ở mức 10.5x P/E 2026F so với trung vị 5 năm trên 18x, tương ứng lợi nhuận kỳ vọng 25% (MUA). Rủi ro: chi tiêu CNTT tại Mỹ/toàn cầu suy yếu, trì hoãn hợp đồng do thuế quan, biến động tỷ giá JPY/USD.</a:t>
+              <a:t>Chúng tôi dự phóng LNST-CĐTS FY26F đạt 10,943 tỷ đồng (+15.6% CK), FY27F đạt 12,518 tỷ đồng (+14.4% CK) và FY28F đạt 14,156 tỷ đồng (+13.1% CK), với giả định lợi nhuận từ FPT Telecom tăng ~15%/năm. Giá mục tiêu theo DCF (FCFF) là 78,750 đồng/cp; tại thị giá 62,900 đồng (24/07/26), FPT giao dịch ở mức 10.4x P/E 2026F so với trung vị 5 năm trên 18x, tương ứng lợi nhuận kỳ vọng 25% (MUA). Rủi ro: chi tiêu CNTT tại Mỹ/toàn cầu suy yếu, trì hoãn hợp đồng do thuế quan, biến động tỷ giá JPY/USD.</a:t>
             </a:r>
             <a:endParaRPr kumimoji="1" lang="en-US" altLang="ko-KR" sz="800" b="0" dirty="0">
               <a:solidFill>
@@ -38810,7 +38810,7 @@
                           <a:effectLst/>
                           <a:latin typeface="Noto Sans" panose="020B0502040504020204" pitchFamily="34" charset="0"/>
                         </a:rPr>
-                        <a:t>57,165</a:t>
+                        <a:t>57,284</a:t>
                       </a:r>
                     </a:p>
                   </a:txBody>
@@ -38863,7 +38863,7 @@
                           <a:effectLst/>
                           <a:latin typeface="Noto Sans" panose="020B0502040504020204" pitchFamily="34" charset="0"/>
                         </a:rPr>
-                        <a:t>65,914</a:t>
+                        <a:t>66,048</a:t>
                       </a:r>
                     </a:p>
                   </a:txBody>
@@ -38913,7 +38913,7 @@
                           <a:effectLst/>
                           <a:latin typeface="Noto Sans" panose="020B0502040504020204" pitchFamily="34" charset="0"/>
                         </a:rPr>
-                        <a:t>76,504</a:t>
+                        <a:t>76,654</a:t>
                       </a:r>
                     </a:p>
                   </a:txBody>
@@ -39142,7 +39142,7 @@
                           <a:effectLst/>
                           <a:latin typeface="Noto Sans" panose="020B0502040504020204" pitchFamily="34" charset="0"/>
                         </a:rPr>
-                        <a:t>9,741</a:t>
+                        <a:t>9,807</a:t>
                       </a:r>
                     </a:p>
                   </a:txBody>
@@ -39188,7 +39188,7 @@
                           <a:effectLst/>
                           <a:latin typeface="Noto Sans" panose="020B0502040504020204" pitchFamily="34" charset="0"/>
                         </a:rPr>
-                        <a:t>10,785</a:t>
+                        <a:t>10,859</a:t>
                       </a:r>
                     </a:p>
                   </a:txBody>
@@ -39231,7 +39231,7 @@
                           <a:effectLst/>
                           <a:latin typeface="Noto Sans" panose="020B0502040504020204" pitchFamily="34" charset="0"/>
                         </a:rPr>
-                        <a:t>12,242</a:t>
+                        <a:t>12,325</a:t>
                       </a:r>
                     </a:p>
                   </a:txBody>
@@ -39468,7 +39468,7 @@
                           <a:effectLst/>
                           <a:latin typeface="Noto Sans" panose="020B0502040504020204" pitchFamily="34" charset="0"/>
                         </a:rPr>
-                        <a:t>12,998</a:t>
+                        <a:t>13,069</a:t>
                       </a:r>
                     </a:p>
                   </a:txBody>
@@ -39517,7 +39517,7 @@
                           <a:effectLst/>
                           <a:latin typeface="Noto Sans" panose="020B0502040504020204" pitchFamily="34" charset="0"/>
                         </a:rPr>
-                        <a:t>14,892</a:t>
+                        <a:t>14,973</a:t>
                       </a:r>
                     </a:p>
                   </a:txBody>
@@ -39563,7 +39563,7 @@
                           <a:effectLst/>
                           <a:latin typeface="Noto Sans" panose="020B0502040504020204" pitchFamily="34" charset="0"/>
                         </a:rPr>
-                        <a:t>16,841</a:t>
+                        <a:t>16,931</a:t>
                       </a:r>
                     </a:p>
                   </a:txBody>
@@ -39800,7 +39800,7 @@
                           <a:effectLst/>
                           <a:latin typeface="Noto Sans" panose="020B0502040504020204" pitchFamily="34" charset="0"/>
                         </a:rPr>
-                        <a:t>10,884</a:t>
+                        <a:t>10,943</a:t>
                       </a:r>
                     </a:p>
                   </a:txBody>
@@ -39849,7 +39849,7 @@
                           <a:effectLst/>
                           <a:latin typeface="Noto Sans" panose="020B0502040504020204" pitchFamily="34" charset="0"/>
                         </a:rPr>
-                        <a:t>12,451</a:t>
+                        <a:t>12,518</a:t>
                       </a:r>
                     </a:p>
                   </a:txBody>
@@ -39895,7 +39895,7 @@
                           <a:effectLst/>
                           <a:latin typeface="Noto Sans" panose="020B0502040504020204" pitchFamily="34" charset="0"/>
                         </a:rPr>
-                        <a:t>14,080</a:t>
+                        <a:t>14,156</a:t>
                       </a:r>
                     </a:p>
                   </a:txBody>
@@ -40132,7 +40132,7 @@
                           <a:effectLst/>
                           <a:latin typeface="Noto Sans" panose="020B0502040504020204" pitchFamily="34" charset="0"/>
                         </a:rPr>
-                        <a:t>6,013</a:t>
+                        <a:t>6,046</a:t>
                       </a:r>
                     </a:p>
                   </a:txBody>
@@ -40181,7 +40181,7 @@
                           <a:effectLst/>
                           <a:latin typeface="Noto Sans" panose="020B0502040504020204" pitchFamily="34" charset="0"/>
                         </a:rPr>
-                        <a:t>6,879</a:t>
+                        <a:t>6,916</a:t>
                       </a:r>
                     </a:p>
                   </a:txBody>
@@ -40227,7 +40227,7 @@
                           <a:effectLst/>
                           <a:latin typeface="Noto Sans" panose="020B0502040504020204" pitchFamily="34" charset="0"/>
                         </a:rPr>
-                        <a:t>7,779</a:t>
+                        <a:t>7,821</a:t>
                       </a:r>
                     </a:p>
                   </a:txBody>
@@ -40464,7 +40464,7 @@
                           <a:effectLst/>
                           <a:latin typeface="Noto Sans" panose="020B0502040504020204" pitchFamily="34" charset="0"/>
                         </a:rPr>
-                        <a:t>27.4</a:t>
+                        <a:t>27.5</a:t>
                       </a:r>
                     </a:p>
                   </a:txBody>
@@ -40513,7 +40513,7 @@
                           <a:effectLst/>
                           <a:latin typeface="Noto Sans" panose="020B0502040504020204" pitchFamily="34" charset="0"/>
                         </a:rPr>
-                        <a:t>26.6</a:t>
+                        <a:t>26.7</a:t>
                       </a:r>
                     </a:p>
                   </a:txBody>
@@ -40559,7 +40559,7 @@
                           <a:effectLst/>
                           <a:latin typeface="Noto Sans" panose="020B0502040504020204" pitchFamily="34" charset="0"/>
                         </a:rPr>
-                        <a:t>25.4</a:t>
+                        <a:t>25.6</a:t>
                       </a:r>
                     </a:p>
                   </a:txBody>
@@ -40796,7 +40796,7 @@
                           <a:effectLst/>
                           <a:latin typeface="Noto Sans" panose="020B0502040504020204" pitchFamily="34" charset="0"/>
                         </a:rPr>
-                        <a:t>13.1</a:t>
+                        <a:t>13.0</a:t>
                       </a:r>
                     </a:p>
                   </a:txBody>
@@ -41485,7 +41485,7 @@
                           <a:effectLst/>
                           <a:latin typeface="Noto Sans" panose="020B0502040504020204" pitchFamily="34" charset="0"/>
                         </a:rPr>
-                        <a:t>91,879</a:t>
+                        <a:t>91,940</a:t>
                       </a:r>
                     </a:p>
                   </a:txBody>
@@ -41538,7 +41538,7 @@
                           <a:effectLst/>
                           <a:latin typeface="Noto Sans" panose="020B0502040504020204" pitchFamily="34" charset="0"/>
                         </a:rPr>
-                        <a:t>102,661</a:t>
+                        <a:t>102,790</a:t>
                       </a:r>
                     </a:p>
                   </a:txBody>
@@ -41588,7 +41588,7 @@
                           <a:effectLst/>
                           <a:latin typeface="Noto Sans" panose="020B0502040504020204" pitchFamily="34" charset="0"/>
                         </a:rPr>
-                        <a:t>114,915</a:t>
+                        <a:t>115,120</a:t>
                       </a:r>
                     </a:p>
                   </a:txBody>
@@ -41854,7 +41854,7 @@
                           <a:effectLst/>
                           <a:latin typeface="Noto Sans" panose="020B0502040504020204" pitchFamily="34" charset="0"/>
                         </a:rPr>
-                        <a:t>50,096</a:t>
+                        <a:t>50,157</a:t>
                       </a:r>
                     </a:p>
                   </a:txBody>
@@ -41907,7 +41907,7 @@
                           <a:effectLst/>
                           <a:latin typeface="Noto Sans" panose="020B0502040504020204" pitchFamily="34" charset="0"/>
                         </a:rPr>
-                        <a:t>58,016</a:t>
+                        <a:t>58,145</a:t>
                       </a:r>
                     </a:p>
                   </a:txBody>
@@ -41957,7 +41957,7 @@
                           <a:effectLst/>
                           <a:latin typeface="Noto Sans" panose="020B0502040504020204" pitchFamily="34" charset="0"/>
                         </a:rPr>
-                        <a:t>67,493</a:t>
+                        <a:t>67,699</a:t>
                       </a:r>
                     </a:p>
                   </a:txBody>
@@ -42214,7 +42214,7 @@
                           <a:effectLst/>
                           <a:latin typeface="Noto Sans" panose="020B0502040504020204" pitchFamily="34" charset="0"/>
                         </a:rPr>
-                        <a:t>25,074</a:t>
+                        <a:t>25,109</a:t>
                       </a:r>
                     </a:p>
                   </a:txBody>
@@ -42267,7 +42267,7 @@
                           <a:effectLst/>
                           <a:latin typeface="Noto Sans" panose="020B0502040504020204" pitchFamily="34" charset="0"/>
                         </a:rPr>
-                        <a:t>29,605</a:t>
+                        <a:t>29,681</a:t>
                       </a:r>
                     </a:p>
                   </a:txBody>
@@ -42317,7 +42317,7 @@
                           <a:effectLst/>
                           <a:latin typeface="Noto Sans" panose="020B0502040504020204" pitchFamily="34" charset="0"/>
                         </a:rPr>
-                        <a:t>35,036</a:t>
+                        <a:t>35,157</a:t>
                       </a:r>
                     </a:p>
                   </a:txBody>

</xml_diff>